<commit_message>
added stewart_platform to algorithms, edited braider icon, corrected braider calculation
</commit_message>
<xml_diff>
--- a/blogs/braider/figures.pptx
+++ b/blogs/braider/figures.pptx
@@ -132,7 +132,7 @@
   <pc:docChgLst>
     <pc:chgData name="Andres Flores" userId="cbb745aa252d2737" providerId="LiveId" clId="{5B02DD72-2521-4955-B22A-9213A9536617}"/>
     <pc:docChg chg="undo redo custSel addSld delSld modSld">
-      <pc:chgData name="Andres Flores" userId="cbb745aa252d2737" providerId="LiveId" clId="{5B02DD72-2521-4955-B22A-9213A9536617}" dt="2026-04-13T22:54:09.888" v="726" actId="21"/>
+      <pc:chgData name="Andres Flores" userId="cbb745aa252d2737" providerId="LiveId" clId="{5B02DD72-2521-4955-B22A-9213A9536617}" dt="2026-04-25T05:55:02.995" v="737" actId="1076"/>
       <pc:docMkLst>
         <pc:docMk/>
       </pc:docMkLst>
@@ -142,140 +142,12 @@
           <pc:docMk/>
           <pc:sldMk cId="1675423220" sldId="256"/>
         </pc:sldMkLst>
-        <pc:spChg chg="add del mod">
-          <ac:chgData name="Andres Flores" userId="cbb745aa252d2737" providerId="LiveId" clId="{5B02DD72-2521-4955-B22A-9213A9536617}" dt="2026-04-13T18:01:00.619" v="6" actId="478"/>
-          <ac:spMkLst>
-            <pc:docMk/>
-            <pc:sldMk cId="1675423220" sldId="256"/>
-            <ac:spMk id="2" creationId="{8E5E8642-1C23-FDEC-3EED-E457635DAE38}"/>
-          </ac:spMkLst>
-        </pc:spChg>
-        <pc:spChg chg="add del mod">
-          <ac:chgData name="Andres Flores" userId="cbb745aa252d2737" providerId="LiveId" clId="{5B02DD72-2521-4955-B22A-9213A9536617}" dt="2026-04-13T18:04:35.410" v="56" actId="478"/>
-          <ac:spMkLst>
-            <pc:docMk/>
-            <pc:sldMk cId="1675423220" sldId="256"/>
-            <ac:spMk id="3" creationId="{B3659173-2FF1-3CF6-A532-054DF5387C4E}"/>
-          </ac:spMkLst>
-        </pc:spChg>
-        <pc:spChg chg="add del mod">
-          <ac:chgData name="Andres Flores" userId="cbb745aa252d2737" providerId="LiveId" clId="{5B02DD72-2521-4955-B22A-9213A9536617}" dt="2026-04-13T18:04:36.532" v="58" actId="478"/>
-          <ac:spMkLst>
-            <pc:docMk/>
-            <pc:sldMk cId="1675423220" sldId="256"/>
-            <ac:spMk id="4" creationId="{9A6514DD-8B01-0EC6-0258-659FC9121E8A}"/>
-          </ac:spMkLst>
-        </pc:spChg>
-        <pc:spChg chg="add del mod">
-          <ac:chgData name="Andres Flores" userId="cbb745aa252d2737" providerId="LiveId" clId="{5B02DD72-2521-4955-B22A-9213A9536617}" dt="2026-04-13T18:02:11.183" v="27" actId="11529"/>
-          <ac:spMkLst>
-            <pc:docMk/>
-            <pc:sldMk cId="1675423220" sldId="256"/>
-            <ac:spMk id="5" creationId="{C5BF621A-E06F-1488-6C5D-3FF355031DD9}"/>
-          </ac:spMkLst>
-        </pc:spChg>
-        <pc:spChg chg="add del mod">
-          <ac:chgData name="Andres Flores" userId="cbb745aa252d2737" providerId="LiveId" clId="{5B02DD72-2521-4955-B22A-9213A9536617}" dt="2026-04-13T18:04:36.027" v="57" actId="478"/>
-          <ac:spMkLst>
-            <pc:docMk/>
-            <pc:sldMk cId="1675423220" sldId="256"/>
-            <ac:spMk id="6" creationId="{8C9F8412-5B13-57F0-6E87-F84B234B895E}"/>
-          </ac:spMkLst>
-        </pc:spChg>
-        <pc:spChg chg="add del mod">
-          <ac:chgData name="Andres Flores" userId="cbb745aa252d2737" providerId="LiveId" clId="{5B02DD72-2521-4955-B22A-9213A9536617}" dt="2026-04-13T18:03:22.641" v="43" actId="478"/>
-          <ac:spMkLst>
-            <pc:docMk/>
-            <pc:sldMk cId="1675423220" sldId="256"/>
-            <ac:spMk id="7" creationId="{A246D8C1-8613-723F-2E5F-E81D7AAAD450}"/>
-          </ac:spMkLst>
-        </pc:spChg>
-        <pc:spChg chg="add del mod">
-          <ac:chgData name="Andres Flores" userId="cbb745aa252d2737" providerId="LiveId" clId="{5B02DD72-2521-4955-B22A-9213A9536617}" dt="2026-04-13T18:04:34.623" v="55" actId="478"/>
-          <ac:spMkLst>
-            <pc:docMk/>
-            <pc:sldMk cId="1675423220" sldId="256"/>
-            <ac:spMk id="8" creationId="{59AC410F-A7CF-CE55-C49B-F971C71EF1F5}"/>
-          </ac:spMkLst>
-        </pc:spChg>
-        <pc:spChg chg="add del mod">
-          <ac:chgData name="Andres Flores" userId="cbb745aa252d2737" providerId="LiveId" clId="{5B02DD72-2521-4955-B22A-9213A9536617}" dt="2026-04-13T18:07:57.912" v="74"/>
-          <ac:spMkLst>
-            <pc:docMk/>
-            <pc:sldMk cId="1675423220" sldId="256"/>
-            <ac:spMk id="14" creationId="{55426F79-851B-541C-7B82-3E3B18E40741}"/>
-          </ac:spMkLst>
-        </pc:spChg>
-        <pc:spChg chg="add del mod">
-          <ac:chgData name="Andres Flores" userId="cbb745aa252d2737" providerId="LiveId" clId="{5B02DD72-2521-4955-B22A-9213A9536617}" dt="2026-04-13T18:07:57.912" v="74"/>
-          <ac:spMkLst>
-            <pc:docMk/>
-            <pc:sldMk cId="1675423220" sldId="256"/>
-            <ac:spMk id="15" creationId="{E55C726F-E7EB-458D-CBF3-0EFDB66EFFEC}"/>
-          </ac:spMkLst>
-        </pc:spChg>
-        <pc:spChg chg="del mod ord">
-          <ac:chgData name="Andres Flores" userId="cbb745aa252d2737" providerId="LiveId" clId="{5B02DD72-2521-4955-B22A-9213A9536617}" dt="2026-04-13T18:58:11.262" v="175"/>
-          <ac:spMkLst>
-            <pc:docMk/>
-            <pc:sldMk cId="1675423220" sldId="256"/>
-            <ac:spMk id="16" creationId="{62CD87EC-9034-6984-2AEC-BFB1A836D01C}"/>
-          </ac:spMkLst>
-        </pc:spChg>
         <pc:spChg chg="add del mod topLvl">
           <ac:chgData name="Andres Flores" userId="cbb745aa252d2737" providerId="LiveId" clId="{5B02DD72-2521-4955-B22A-9213A9536617}" dt="2026-04-13T19:13:55.660" v="286" actId="1076"/>
           <ac:spMkLst>
             <pc:docMk/>
             <pc:sldMk cId="1675423220" sldId="256"/>
             <ac:spMk id="17" creationId="{18669597-4F88-D3D2-C300-C4A2C46B03D5}"/>
-          </ac:spMkLst>
-        </pc:spChg>
-        <pc:spChg chg="add del mod ord">
-          <ac:chgData name="Andres Flores" userId="cbb745aa252d2737" providerId="LiveId" clId="{5B02DD72-2521-4955-B22A-9213A9536617}" dt="2026-04-13T18:58:11.262" v="175"/>
-          <ac:spMkLst>
-            <pc:docMk/>
-            <pc:sldMk cId="1675423220" sldId="256"/>
-            <ac:spMk id="18" creationId="{DC40C7B9-55E9-8D0D-D4AB-60271B327071}"/>
-          </ac:spMkLst>
-        </pc:spChg>
-        <pc:spChg chg="add del mod">
-          <ac:chgData name="Andres Flores" userId="cbb745aa252d2737" providerId="LiveId" clId="{5B02DD72-2521-4955-B22A-9213A9536617}" dt="2026-04-13T18:17:24.751" v="143" actId="21"/>
-          <ac:spMkLst>
-            <pc:docMk/>
-            <pc:sldMk cId="1675423220" sldId="256"/>
-            <ac:spMk id="19" creationId="{283EA541-D3F5-B98A-3427-47F0232F7DC6}"/>
-          </ac:spMkLst>
-        </pc:spChg>
-        <pc:spChg chg="add del mod">
-          <ac:chgData name="Andres Flores" userId="cbb745aa252d2737" providerId="LiveId" clId="{5B02DD72-2521-4955-B22A-9213A9536617}" dt="2026-04-13T18:57:34.926" v="167" actId="21"/>
-          <ac:spMkLst>
-            <pc:docMk/>
-            <pc:sldMk cId="1675423220" sldId="256"/>
-            <ac:spMk id="25" creationId="{AA77C73F-86C3-1D79-D3A0-7214243815AD}"/>
-          </ac:spMkLst>
-        </pc:spChg>
-        <pc:spChg chg="add del mod">
-          <ac:chgData name="Andres Flores" userId="cbb745aa252d2737" providerId="LiveId" clId="{5B02DD72-2521-4955-B22A-9213A9536617}" dt="2026-04-13T18:57:34.926" v="167" actId="21"/>
-          <ac:spMkLst>
-            <pc:docMk/>
-            <pc:sldMk cId="1675423220" sldId="256"/>
-            <ac:spMk id="32" creationId="{283EA541-D3F5-B98A-3427-47F0232F7DC6}"/>
-          </ac:spMkLst>
-        </pc:spChg>
-        <pc:spChg chg="add mod">
-          <ac:chgData name="Andres Flores" userId="cbb745aa252d2737" providerId="LiveId" clId="{5B02DD72-2521-4955-B22A-9213A9536617}" dt="2026-04-13T18:57:47.336" v="170"/>
-          <ac:spMkLst>
-            <pc:docMk/>
-            <pc:sldMk cId="1675423220" sldId="256"/>
-            <ac:spMk id="34" creationId="{AA77C73F-86C3-1D79-D3A0-7214243815AD}"/>
-          </ac:spMkLst>
-        </pc:spChg>
-        <pc:spChg chg="add mod">
-          <ac:chgData name="Andres Flores" userId="cbb745aa252d2737" providerId="LiveId" clId="{5B02DD72-2521-4955-B22A-9213A9536617}" dt="2026-04-13T18:57:47.336" v="170"/>
-          <ac:spMkLst>
-            <pc:docMk/>
-            <pc:sldMk cId="1675423220" sldId="256"/>
-            <ac:spMk id="36" creationId="{283EA541-D3F5-B98A-3427-47F0232F7DC6}"/>
           </ac:spMkLst>
         </pc:spChg>
         <pc:spChg chg="add del mod">
@@ -302,30 +174,6 @@
             <ac:spMk id="41" creationId="{E3B28089-B57B-448D-B21C-B32EF9AE4667}"/>
           </ac:spMkLst>
         </pc:spChg>
-        <pc:spChg chg="add del mod">
-          <ac:chgData name="Andres Flores" userId="cbb745aa252d2737" providerId="LiveId" clId="{5B02DD72-2521-4955-B22A-9213A9536617}" dt="2026-04-13T19:11:45.995" v="260" actId="478"/>
-          <ac:spMkLst>
-            <pc:docMk/>
-            <pc:sldMk cId="1675423220" sldId="256"/>
-            <ac:spMk id="44" creationId="{482331EA-5BF9-A90F-1BD5-25862658C081}"/>
-          </ac:spMkLst>
-        </pc:spChg>
-        <pc:spChg chg="add del mod">
-          <ac:chgData name="Andres Flores" userId="cbb745aa252d2737" providerId="LiveId" clId="{5B02DD72-2521-4955-B22A-9213A9536617}" dt="2026-04-13T19:11:50.636" v="264" actId="478"/>
-          <ac:spMkLst>
-            <pc:docMk/>
-            <pc:sldMk cId="1675423220" sldId="256"/>
-            <ac:spMk id="50" creationId="{EC6F4D0B-D4B5-EC37-628E-BD8585CD998A}"/>
-          </ac:spMkLst>
-        </pc:spChg>
-        <pc:spChg chg="add del mod">
-          <ac:chgData name="Andres Flores" userId="cbb745aa252d2737" providerId="LiveId" clId="{5B02DD72-2521-4955-B22A-9213A9536617}" dt="2026-04-13T19:11:47.474" v="261" actId="478"/>
-          <ac:spMkLst>
-            <pc:docMk/>
-            <pc:sldMk cId="1675423220" sldId="256"/>
-            <ac:spMk id="51" creationId="{B1C15071-1C64-A4FB-99F4-6823533A3EA1}"/>
-          </ac:spMkLst>
-        </pc:spChg>
         <pc:grpChg chg="add mod topLvl">
           <ac:chgData name="Andres Flores" userId="cbb745aa252d2737" providerId="LiveId" clId="{5B02DD72-2521-4955-B22A-9213A9536617}" dt="2026-04-13T19:12:39.578" v="271" actId="21"/>
           <ac:grpSpMkLst>
@@ -342,54 +190,6 @@
             <ac:grpSpMk id="43" creationId="{97094F47-3185-209C-AE29-660518BC12AC}"/>
           </ac:grpSpMkLst>
         </pc:grpChg>
-        <pc:picChg chg="add del mod ord">
-          <ac:chgData name="Andres Flores" userId="cbb745aa252d2737" providerId="LiveId" clId="{5B02DD72-2521-4955-B22A-9213A9536617}" dt="2026-04-13T18:17:24.751" v="143" actId="21"/>
-          <ac:picMkLst>
-            <pc:docMk/>
-            <pc:sldMk cId="1675423220" sldId="256"/>
-            <ac:picMk id="27" creationId="{A841FC45-622F-A99F-0632-207410A475FD}"/>
-          </ac:picMkLst>
-        </pc:picChg>
-        <pc:picChg chg="add del mod ord">
-          <ac:chgData name="Andres Flores" userId="cbb745aa252d2737" providerId="LiveId" clId="{5B02DD72-2521-4955-B22A-9213A9536617}" dt="2026-04-13T18:17:24.751" v="143" actId="21"/>
-          <ac:picMkLst>
-            <pc:docMk/>
-            <pc:sldMk cId="1675423220" sldId="256"/>
-            <ac:picMk id="29" creationId="{6BE23160-3FC6-7494-0B3F-13A18B626167}"/>
-          </ac:picMkLst>
-        </pc:picChg>
-        <pc:picChg chg="add del mod">
-          <ac:chgData name="Andres Flores" userId="cbb745aa252d2737" providerId="LiveId" clId="{5B02DD72-2521-4955-B22A-9213A9536617}" dt="2026-04-13T18:57:34.926" v="167" actId="21"/>
-          <ac:picMkLst>
-            <pc:docMk/>
-            <pc:sldMk cId="1675423220" sldId="256"/>
-            <ac:picMk id="30" creationId="{A841FC45-622F-A99F-0632-207410A475FD}"/>
-          </ac:picMkLst>
-        </pc:picChg>
-        <pc:picChg chg="add del mod ord">
-          <ac:chgData name="Andres Flores" userId="cbb745aa252d2737" providerId="LiveId" clId="{5B02DD72-2521-4955-B22A-9213A9536617}" dt="2026-04-13T18:57:34.926" v="167" actId="21"/>
-          <ac:picMkLst>
-            <pc:docMk/>
-            <pc:sldMk cId="1675423220" sldId="256"/>
-            <ac:picMk id="31" creationId="{6BE23160-3FC6-7494-0B3F-13A18B626167}"/>
-          </ac:picMkLst>
-        </pc:picChg>
-        <pc:picChg chg="add mod">
-          <ac:chgData name="Andres Flores" userId="cbb745aa252d2737" providerId="LiveId" clId="{5B02DD72-2521-4955-B22A-9213A9536617}" dt="2026-04-13T18:57:47.336" v="170"/>
-          <ac:picMkLst>
-            <pc:docMk/>
-            <pc:sldMk cId="1675423220" sldId="256"/>
-            <ac:picMk id="33" creationId="{6BE23160-3FC6-7494-0B3F-13A18B626167}"/>
-          </ac:picMkLst>
-        </pc:picChg>
-        <pc:picChg chg="add mod">
-          <ac:chgData name="Andres Flores" userId="cbb745aa252d2737" providerId="LiveId" clId="{5B02DD72-2521-4955-B22A-9213A9536617}" dt="2026-04-13T18:57:47.336" v="170"/>
-          <ac:picMkLst>
-            <pc:docMk/>
-            <pc:sldMk cId="1675423220" sldId="256"/>
-            <ac:picMk id="35" creationId="{A841FC45-622F-A99F-0632-207410A475FD}"/>
-          </ac:picMkLst>
-        </pc:picChg>
         <pc:picChg chg="add mod">
           <ac:chgData name="Andres Flores" userId="cbb745aa252d2737" providerId="LiveId" clId="{5B02DD72-2521-4955-B22A-9213A9536617}" dt="2026-04-13T18:59:44.839" v="189" actId="164"/>
           <ac:picMkLst>
@@ -414,163 +214,19 @@
             <ac:picMk id="53" creationId="{218BF04B-1E6D-7770-256D-D70724E47C6D}"/>
           </ac:picMkLst>
         </pc:picChg>
-        <pc:picChg chg="add del mod">
-          <ac:chgData name="Andres Flores" userId="cbb745aa252d2737" providerId="LiveId" clId="{5B02DD72-2521-4955-B22A-9213A9536617}" dt="2026-04-13T18:05:58.464" v="63" actId="478"/>
-          <ac:picMkLst>
-            <pc:docMk/>
-            <pc:sldMk cId="1675423220" sldId="256"/>
-            <ac:picMk id="1026" creationId="{B7D62343-FEDA-BF67-602D-F09735EA3637}"/>
-          </ac:picMkLst>
-        </pc:picChg>
-        <pc:picChg chg="add del">
-          <ac:chgData name="Andres Flores" userId="cbb745aa252d2737" providerId="LiveId" clId="{5B02DD72-2521-4955-B22A-9213A9536617}" dt="2026-04-13T18:05:58.464" v="63" actId="478"/>
-          <ac:picMkLst>
-            <pc:docMk/>
-            <pc:sldMk cId="1675423220" sldId="256"/>
-            <ac:picMk id="1028" creationId="{C9179ECF-5F6D-3875-C0D3-EE91475E45E5}"/>
-          </ac:picMkLst>
-        </pc:picChg>
-        <pc:cxnChg chg="add del mod">
-          <ac:chgData name="Andres Flores" userId="cbb745aa252d2737" providerId="LiveId" clId="{5B02DD72-2521-4955-B22A-9213A9536617}" dt="2026-04-13T18:04:16.206" v="53" actId="478"/>
-          <ac:cxnSpMkLst>
-            <pc:docMk/>
-            <pc:sldMk cId="1675423220" sldId="256"/>
-            <ac:cxnSpMk id="10" creationId="{29515B23-9265-BAB2-B50D-55D521F43D8D}"/>
-          </ac:cxnSpMkLst>
-        </pc:cxnChg>
-        <pc:cxnChg chg="add del mod">
-          <ac:chgData name="Andres Flores" userId="cbb745aa252d2737" providerId="LiveId" clId="{5B02DD72-2521-4955-B22A-9213A9536617}" dt="2026-04-13T18:10:27.568" v="101" actId="478"/>
-          <ac:cxnSpMkLst>
-            <pc:docMk/>
-            <pc:sldMk cId="1675423220" sldId="256"/>
-            <ac:cxnSpMk id="21" creationId="{ABF5EA70-49E5-C606-C9AC-D38BDA212C61}"/>
-          </ac:cxnSpMkLst>
-        </pc:cxnChg>
-        <pc:cxnChg chg="add del mod">
-          <ac:chgData name="Andres Flores" userId="cbb745aa252d2737" providerId="LiveId" clId="{5B02DD72-2521-4955-B22A-9213A9536617}" dt="2026-04-13T19:11:48.301" v="262" actId="478"/>
-          <ac:cxnSpMkLst>
-            <pc:docMk/>
-            <pc:sldMk cId="1675423220" sldId="256"/>
-            <ac:cxnSpMk id="46" creationId="{9C44BE0D-D17D-5C60-B58C-B963C1844D9D}"/>
-          </ac:cxnSpMkLst>
-        </pc:cxnChg>
-        <pc:cxnChg chg="add del mod">
-          <ac:chgData name="Andres Flores" userId="cbb745aa252d2737" providerId="LiveId" clId="{5B02DD72-2521-4955-B22A-9213A9536617}" dt="2026-04-13T19:11:49.639" v="263" actId="478"/>
-          <ac:cxnSpMkLst>
-            <pc:docMk/>
-            <pc:sldMk cId="1675423220" sldId="256"/>
-            <ac:cxnSpMk id="49" creationId="{795A32F0-901C-DF05-56FC-DC8D8F495D81}"/>
-          </ac:cxnSpMkLst>
-        </pc:cxnChg>
       </pc:sldChg>
       <pc:sldChg chg="addSp delSp modSp new mod">
-        <pc:chgData name="Andres Flores" userId="cbb745aa252d2737" providerId="LiveId" clId="{5B02DD72-2521-4955-B22A-9213A9536617}" dt="2026-04-13T22:23:12.206" v="640" actId="164"/>
+        <pc:chgData name="Andres Flores" userId="cbb745aa252d2737" providerId="LiveId" clId="{5B02DD72-2521-4955-B22A-9213A9536617}" dt="2026-04-25T05:53:49.736" v="730" actId="207"/>
         <pc:sldMkLst>
           <pc:docMk/>
           <pc:sldMk cId="4172594200" sldId="257"/>
         </pc:sldMkLst>
         <pc:spChg chg="add mod topLvl">
-          <ac:chgData name="Andres Flores" userId="cbb745aa252d2737" providerId="LiveId" clId="{5B02DD72-2521-4955-B22A-9213A9536617}" dt="2026-04-13T20:12:45.155" v="584" actId="164"/>
+          <ac:chgData name="Andres Flores" userId="cbb745aa252d2737" providerId="LiveId" clId="{5B02DD72-2521-4955-B22A-9213A9536617}" dt="2026-04-25T05:53:49.736" v="730" actId="207"/>
           <ac:spMkLst>
             <pc:docMk/>
             <pc:sldMk cId="4172594200" sldId="257"/>
             <ac:spMk id="2" creationId="{CE10BA7F-77DF-B148-F4DC-38E6CA3E7AD3}"/>
-          </ac:spMkLst>
-        </pc:spChg>
-        <pc:spChg chg="mod">
-          <ac:chgData name="Andres Flores" userId="cbb745aa252d2737" providerId="LiveId" clId="{5B02DD72-2521-4955-B22A-9213A9536617}" dt="2026-04-13T19:05:25.410" v="212"/>
-          <ac:spMkLst>
-            <pc:docMk/>
-            <pc:sldMk cId="4172594200" sldId="257"/>
-            <ac:spMk id="4" creationId="{6BFB118C-D36F-60B1-9807-F8F80CE9A7C2}"/>
-          </ac:spMkLst>
-        </pc:spChg>
-        <pc:spChg chg="mod">
-          <ac:chgData name="Andres Flores" userId="cbb745aa252d2737" providerId="LiveId" clId="{5B02DD72-2521-4955-B22A-9213A9536617}" dt="2026-04-13T19:59:27.368" v="563"/>
-          <ac:spMkLst>
-            <pc:docMk/>
-            <pc:sldMk cId="4172594200" sldId="257"/>
-            <ac:spMk id="5" creationId="{E38FCFC0-AEB4-432A-4635-432C09771C78}"/>
-          </ac:spMkLst>
-        </pc:spChg>
-        <pc:spChg chg="mod">
-          <ac:chgData name="Andres Flores" userId="cbb745aa252d2737" providerId="LiveId" clId="{5B02DD72-2521-4955-B22A-9213A9536617}" dt="2026-04-13T19:05:25.410" v="212"/>
-          <ac:spMkLst>
-            <pc:docMk/>
-            <pc:sldMk cId="4172594200" sldId="257"/>
-            <ac:spMk id="6" creationId="{40A7A3FF-75C5-2B20-978E-C59144E7B35C}"/>
-          </ac:spMkLst>
-        </pc:spChg>
-        <pc:spChg chg="mod">
-          <ac:chgData name="Andres Flores" userId="cbb745aa252d2737" providerId="LiveId" clId="{5B02DD72-2521-4955-B22A-9213A9536617}" dt="2026-04-13T19:05:25.410" v="212"/>
-          <ac:spMkLst>
-            <pc:docMk/>
-            <pc:sldMk cId="4172594200" sldId="257"/>
-            <ac:spMk id="8" creationId="{1FE47B95-7F20-6E42-15B5-C04A012531A5}"/>
-          </ac:spMkLst>
-        </pc:spChg>
-        <pc:spChg chg="mod">
-          <ac:chgData name="Andres Flores" userId="cbb745aa252d2737" providerId="LiveId" clId="{5B02DD72-2521-4955-B22A-9213A9536617}" dt="2026-04-13T19:05:25.410" v="212"/>
-          <ac:spMkLst>
-            <pc:docMk/>
-            <pc:sldMk cId="4172594200" sldId="257"/>
-            <ac:spMk id="10" creationId="{0A925821-91FD-5955-11D1-4AF0FC4EC719}"/>
-          </ac:spMkLst>
-        </pc:spChg>
-        <pc:spChg chg="mod">
-          <ac:chgData name="Andres Flores" userId="cbb745aa252d2737" providerId="LiveId" clId="{5B02DD72-2521-4955-B22A-9213A9536617}" dt="2026-04-13T19:59:27.368" v="563"/>
-          <ac:spMkLst>
-            <pc:docMk/>
-            <pc:sldMk cId="4172594200" sldId="257"/>
-            <ac:spMk id="11" creationId="{3CE2212B-5351-A259-32D8-93C4590186BF}"/>
-          </ac:spMkLst>
-        </pc:spChg>
-        <pc:spChg chg="mod">
-          <ac:chgData name="Andres Flores" userId="cbb745aa252d2737" providerId="LiveId" clId="{5B02DD72-2521-4955-B22A-9213A9536617}" dt="2026-04-13T19:05:53.487" v="218" actId="571"/>
-          <ac:spMkLst>
-            <pc:docMk/>
-            <pc:sldMk cId="4172594200" sldId="257"/>
-            <ac:spMk id="12" creationId="{0CA0D97B-D244-4D6B-155F-664146CCF10E}"/>
-          </ac:spMkLst>
-        </pc:spChg>
-        <pc:spChg chg="mod">
-          <ac:chgData name="Andres Flores" userId="cbb745aa252d2737" providerId="LiveId" clId="{5B02DD72-2521-4955-B22A-9213A9536617}" dt="2026-04-13T19:59:27.368" v="563"/>
-          <ac:spMkLst>
-            <pc:docMk/>
-            <pc:sldMk cId="4172594200" sldId="257"/>
-            <ac:spMk id="12" creationId="{1414DD9C-6C9C-B2D4-7977-A35899DBD1ED}"/>
-          </ac:spMkLst>
-        </pc:spChg>
-        <pc:spChg chg="mod">
-          <ac:chgData name="Andres Flores" userId="cbb745aa252d2737" providerId="LiveId" clId="{5B02DD72-2521-4955-B22A-9213A9536617}" dt="2026-04-13T19:59:27.368" v="563"/>
-          <ac:spMkLst>
-            <pc:docMk/>
-            <pc:sldMk cId="4172594200" sldId="257"/>
-            <ac:spMk id="13" creationId="{0F98BC8E-1668-AC56-9B1D-24638D3AEED4}"/>
-          </ac:spMkLst>
-        </pc:spChg>
-        <pc:spChg chg="mod">
-          <ac:chgData name="Andres Flores" userId="cbb745aa252d2737" providerId="LiveId" clId="{5B02DD72-2521-4955-B22A-9213A9536617}" dt="2026-04-13T19:05:53.487" v="218" actId="571"/>
-          <ac:spMkLst>
-            <pc:docMk/>
-            <pc:sldMk cId="4172594200" sldId="257"/>
-            <ac:spMk id="14" creationId="{C096915D-7924-AF1F-726A-B738D0CB5751}"/>
-          </ac:spMkLst>
-        </pc:spChg>
-        <pc:spChg chg="mod">
-          <ac:chgData name="Andres Flores" userId="cbb745aa252d2737" providerId="LiveId" clId="{5B02DD72-2521-4955-B22A-9213A9536617}" dt="2026-04-13T19:05:53.487" v="218" actId="571"/>
-          <ac:spMkLst>
-            <pc:docMk/>
-            <pc:sldMk cId="4172594200" sldId="257"/>
-            <ac:spMk id="16" creationId="{CD1A54BF-AB72-9B44-1B98-E70FF5FF3265}"/>
-          </ac:spMkLst>
-        </pc:spChg>
-        <pc:spChg chg="mod">
-          <ac:chgData name="Andres Flores" userId="cbb745aa252d2737" providerId="LiveId" clId="{5B02DD72-2521-4955-B22A-9213A9536617}" dt="2026-04-13T19:05:53.487" v="218" actId="571"/>
-          <ac:spMkLst>
-            <pc:docMk/>
-            <pc:sldMk cId="4172594200" sldId="257"/>
-            <ac:spMk id="18" creationId="{252E4F1F-8034-185F-C779-66EC562A9284}"/>
           </ac:spMkLst>
         </pc:spChg>
         <pc:spChg chg="add mod topLvl">
@@ -581,92 +237,12 @@
             <ac:spMk id="19" creationId="{161ACDC7-DC6B-E24F-ED3F-9E762501C945}"/>
           </ac:spMkLst>
         </pc:spChg>
-        <pc:spChg chg="mod">
-          <ac:chgData name="Andres Flores" userId="cbb745aa252d2737" providerId="LiveId" clId="{5B02DD72-2521-4955-B22A-9213A9536617}" dt="2026-04-13T19:31:53.731" v="532"/>
-          <ac:spMkLst>
-            <pc:docMk/>
-            <pc:sldMk cId="4172594200" sldId="257"/>
-            <ac:spMk id="21" creationId="{8D55F7CC-EF2C-446F-7D5C-98BAA43542C4}"/>
-          </ac:spMkLst>
-        </pc:spChg>
-        <pc:spChg chg="mod">
-          <ac:chgData name="Andres Flores" userId="cbb745aa252d2737" providerId="LiveId" clId="{5B02DD72-2521-4955-B22A-9213A9536617}" dt="2026-04-13T19:31:53.731" v="532"/>
-          <ac:spMkLst>
-            <pc:docMk/>
-            <pc:sldMk cId="4172594200" sldId="257"/>
-            <ac:spMk id="27" creationId="{1F6252AF-AB02-0652-84C3-D610DA37B7C4}"/>
-          </ac:spMkLst>
-        </pc:spChg>
-        <pc:spChg chg="mod">
-          <ac:chgData name="Andres Flores" userId="cbb745aa252d2737" providerId="LiveId" clId="{5B02DD72-2521-4955-B22A-9213A9536617}" dt="2026-04-13T19:31:53.731" v="532"/>
-          <ac:spMkLst>
-            <pc:docMk/>
-            <pc:sldMk cId="4172594200" sldId="257"/>
-            <ac:spMk id="28" creationId="{D431CF1E-BAAA-2FE2-DD46-A85183D6FC3E}"/>
-          </ac:spMkLst>
-        </pc:spChg>
-        <pc:spChg chg="mod">
-          <ac:chgData name="Andres Flores" userId="cbb745aa252d2737" providerId="LiveId" clId="{5B02DD72-2521-4955-B22A-9213A9536617}" dt="2026-04-13T19:31:53.731" v="532"/>
-          <ac:spMkLst>
-            <pc:docMk/>
-            <pc:sldMk cId="4172594200" sldId="257"/>
-            <ac:spMk id="29" creationId="{1D9AFDD9-38A6-87F7-D1BE-03EE10E7F036}"/>
-          </ac:spMkLst>
-        </pc:spChg>
-        <pc:grpChg chg="del">
-          <ac:chgData name="Andres Flores" userId="cbb745aa252d2737" providerId="LiveId" clId="{5B02DD72-2521-4955-B22A-9213A9536617}" dt="2026-04-13T19:59:20.792" v="560" actId="165"/>
-          <ac:grpSpMkLst>
-            <pc:docMk/>
-            <pc:sldMk cId="4172594200" sldId="257"/>
-            <ac:grpSpMk id="3" creationId="{3CE3232E-16B3-BA32-BA2D-A459A3F263A0}"/>
-          </ac:grpSpMkLst>
-        </pc:grpChg>
-        <pc:grpChg chg="add del mod">
-          <ac:chgData name="Andres Flores" userId="cbb745aa252d2737" providerId="LiveId" clId="{5B02DD72-2521-4955-B22A-9213A9536617}" dt="2026-04-13T19:32:20.819" v="541" actId="478"/>
-          <ac:grpSpMkLst>
-            <pc:docMk/>
-            <pc:sldMk cId="4172594200" sldId="257"/>
-            <ac:grpSpMk id="3" creationId="{974887F0-DAC0-06A9-D64B-B922592F6002}"/>
-          </ac:grpSpMkLst>
-        </pc:grpChg>
-        <pc:grpChg chg="add mod">
-          <ac:chgData name="Andres Flores" userId="cbb745aa252d2737" providerId="LiveId" clId="{5B02DD72-2521-4955-B22A-9213A9536617}" dt="2026-04-13T19:59:27.368" v="563"/>
-          <ac:grpSpMkLst>
-            <pc:docMk/>
-            <pc:sldMk cId="4172594200" sldId="257"/>
-            <ac:grpSpMk id="4" creationId="{1BC51001-DB7F-4AA3-4611-8B63DF519F5A}"/>
-          </ac:grpSpMkLst>
-        </pc:grpChg>
         <pc:grpChg chg="add mod">
           <ac:chgData name="Andres Flores" userId="cbb745aa252d2737" providerId="LiveId" clId="{5B02DD72-2521-4955-B22A-9213A9536617}" dt="2026-04-13T22:23:12.206" v="640" actId="164"/>
           <ac:grpSpMkLst>
             <pc:docMk/>
             <pc:sldMk cId="4172594200" sldId="257"/>
             <ac:grpSpMk id="5" creationId="{079A03B7-A826-AF9B-F7F4-57025A1BCF47}"/>
-          </ac:grpSpMkLst>
-        </pc:grpChg>
-        <pc:grpChg chg="mod">
-          <ac:chgData name="Andres Flores" userId="cbb745aa252d2737" providerId="LiveId" clId="{5B02DD72-2521-4955-B22A-9213A9536617}" dt="2026-04-13T19:05:25.410" v="212"/>
-          <ac:grpSpMkLst>
-            <pc:docMk/>
-            <pc:sldMk cId="4172594200" sldId="257"/>
-            <ac:grpSpMk id="5" creationId="{C7D2F91B-887F-DD88-8C36-F85A02E6F3F7}"/>
-          </ac:grpSpMkLst>
-        </pc:grpChg>
-        <pc:grpChg chg="add mod">
-          <ac:chgData name="Andres Flores" userId="cbb745aa252d2737" providerId="LiveId" clId="{5B02DD72-2521-4955-B22A-9213A9536617}" dt="2026-04-13T19:05:53.487" v="218" actId="571"/>
-          <ac:grpSpMkLst>
-            <pc:docMk/>
-            <pc:sldMk cId="4172594200" sldId="257"/>
-            <ac:grpSpMk id="11" creationId="{FAAED4FB-5039-22DA-CC92-A5F495095620}"/>
-          </ac:grpSpMkLst>
-        </pc:grpChg>
-        <pc:grpChg chg="mod">
-          <ac:chgData name="Andres Flores" userId="cbb745aa252d2737" providerId="LiveId" clId="{5B02DD72-2521-4955-B22A-9213A9536617}" dt="2026-04-13T19:05:53.487" v="218" actId="571"/>
-          <ac:grpSpMkLst>
-            <pc:docMk/>
-            <pc:sldMk cId="4172594200" sldId="257"/>
-            <ac:grpSpMk id="13" creationId="{29D8CB87-CBA7-C7A8-BE1D-C569D163C4FE}"/>
           </ac:grpSpMkLst>
         </pc:grpChg>
         <pc:grpChg chg="add del mod">
@@ -677,195 +253,12 @@
             <ac:grpSpMk id="16" creationId="{5DB0956C-258D-55D9-CA80-AFEB42E6A57D}"/>
           </ac:grpSpMkLst>
         </pc:grpChg>
-        <pc:grpChg chg="add mod">
-          <ac:chgData name="Andres Flores" userId="cbb745aa252d2737" providerId="LiveId" clId="{5B02DD72-2521-4955-B22A-9213A9536617}" dt="2026-04-13T19:31:53.731" v="532"/>
-          <ac:grpSpMkLst>
-            <pc:docMk/>
-            <pc:sldMk cId="4172594200" sldId="257"/>
-            <ac:grpSpMk id="20" creationId="{5EFD1E2A-99FE-1190-91D6-CE89B97BC16A}"/>
-          </ac:grpSpMkLst>
-        </pc:grpChg>
-        <pc:picChg chg="add mod">
-          <ac:chgData name="Andres Flores" userId="cbb745aa252d2737" providerId="LiveId" clId="{5B02DD72-2521-4955-B22A-9213A9536617}" dt="2026-04-13T22:22:16.929" v="633"/>
-          <ac:picMkLst>
-            <pc:docMk/>
-            <pc:sldMk cId="4172594200" sldId="257"/>
-            <ac:picMk id="3" creationId="{31034980-41EB-4AF2-4FAD-9A4031392A5A}"/>
-          </ac:picMkLst>
-        </pc:picChg>
         <pc:picChg chg="add mod">
           <ac:chgData name="Andres Flores" userId="cbb745aa252d2737" providerId="LiveId" clId="{5B02DD72-2521-4955-B22A-9213A9536617}" dt="2026-04-13T22:23:12.206" v="640" actId="164"/>
           <ac:picMkLst>
             <pc:docMk/>
             <pc:sldMk cId="4172594200" sldId="257"/>
             <ac:picMk id="4" creationId="{072892DB-0461-128C-538F-8DD1AA9105C3}"/>
-          </ac:picMkLst>
-        </pc:picChg>
-        <pc:picChg chg="mod">
-          <ac:chgData name="Andres Flores" userId="cbb745aa252d2737" providerId="LiveId" clId="{5B02DD72-2521-4955-B22A-9213A9536617}" dt="2026-04-13T19:59:27.368" v="563"/>
-          <ac:picMkLst>
-            <pc:docMk/>
-            <pc:sldMk cId="4172594200" sldId="257"/>
-            <ac:picMk id="6" creationId="{5BCB84E2-9D24-7B86-1FB8-60F4B4C4FD09}"/>
-          </ac:picMkLst>
-        </pc:picChg>
-        <pc:picChg chg="mod">
-          <ac:chgData name="Andres Flores" userId="cbb745aa252d2737" providerId="LiveId" clId="{5B02DD72-2521-4955-B22A-9213A9536617}" dt="2026-04-13T19:59:27.368" v="563"/>
-          <ac:picMkLst>
-            <pc:docMk/>
-            <pc:sldMk cId="4172594200" sldId="257"/>
-            <ac:picMk id="7" creationId="{1D253E28-C4B4-3240-724F-13A01F819E7B}"/>
-          </ac:picMkLst>
-        </pc:picChg>
-        <pc:picChg chg="mod">
-          <ac:chgData name="Andres Flores" userId="cbb745aa252d2737" providerId="LiveId" clId="{5B02DD72-2521-4955-B22A-9213A9536617}" dt="2026-04-13T19:05:25.410" v="212"/>
-          <ac:picMkLst>
-            <pc:docMk/>
-            <pc:sldMk cId="4172594200" sldId="257"/>
-            <ac:picMk id="7" creationId="{DC219AA1-6D41-B60F-7F5E-AAA42A83910F}"/>
-          </ac:picMkLst>
-        </pc:picChg>
-        <pc:picChg chg="mod">
-          <ac:chgData name="Andres Flores" userId="cbb745aa252d2737" providerId="LiveId" clId="{5B02DD72-2521-4955-B22A-9213A9536617}" dt="2026-04-13T19:59:27.368" v="563"/>
-          <ac:picMkLst>
-            <pc:docMk/>
-            <pc:sldMk cId="4172594200" sldId="257"/>
-            <ac:picMk id="8" creationId="{53B898EE-A940-7501-6294-06E7DEDF8C6D}"/>
-          </ac:picMkLst>
-        </pc:picChg>
-        <pc:picChg chg="mod">
-          <ac:chgData name="Andres Flores" userId="cbb745aa252d2737" providerId="LiveId" clId="{5B02DD72-2521-4955-B22A-9213A9536617}" dt="2026-04-13T19:59:27.368" v="563"/>
-          <ac:picMkLst>
-            <pc:docMk/>
-            <pc:sldMk cId="4172594200" sldId="257"/>
-            <ac:picMk id="9" creationId="{722E4F8F-D85F-D6D1-606E-36E43078F9CE}"/>
-          </ac:picMkLst>
-        </pc:picChg>
-        <pc:picChg chg="mod">
-          <ac:chgData name="Andres Flores" userId="cbb745aa252d2737" providerId="LiveId" clId="{5B02DD72-2521-4955-B22A-9213A9536617}" dt="2026-04-13T19:05:25.410" v="212"/>
-          <ac:picMkLst>
-            <pc:docMk/>
-            <pc:sldMk cId="4172594200" sldId="257"/>
-            <ac:picMk id="9" creationId="{8A7CC94D-EB13-56EE-31B6-B450FA84AD19}"/>
-          </ac:picMkLst>
-        </pc:picChg>
-        <pc:picChg chg="mod">
-          <ac:chgData name="Andres Flores" userId="cbb745aa252d2737" providerId="LiveId" clId="{5B02DD72-2521-4955-B22A-9213A9536617}" dt="2026-04-13T19:59:27.368" v="563"/>
-          <ac:picMkLst>
-            <pc:docMk/>
-            <pc:sldMk cId="4172594200" sldId="257"/>
-            <ac:picMk id="10" creationId="{0E12173A-DD3D-1D75-A0E1-801ED62F5DD2}"/>
-          </ac:picMkLst>
-        </pc:picChg>
-        <pc:picChg chg="add del mod">
-          <ac:chgData name="Andres Flores" userId="cbb745aa252d2737" providerId="LiveId" clId="{5B02DD72-2521-4955-B22A-9213A9536617}" dt="2026-04-13T22:22:06.341" v="631" actId="478"/>
-          <ac:picMkLst>
-            <pc:docMk/>
-            <pc:sldMk cId="4172594200" sldId="257"/>
-            <ac:picMk id="15" creationId="{4279613E-D535-2B6B-F15F-33B774D0FBD1}"/>
-          </ac:picMkLst>
-        </pc:picChg>
-        <pc:picChg chg="mod">
-          <ac:chgData name="Andres Flores" userId="cbb745aa252d2737" providerId="LiveId" clId="{5B02DD72-2521-4955-B22A-9213A9536617}" dt="2026-04-13T19:05:53.487" v="218" actId="571"/>
-          <ac:picMkLst>
-            <pc:docMk/>
-            <pc:sldMk cId="4172594200" sldId="257"/>
-            <ac:picMk id="15" creationId="{C56454AF-565A-E669-BDE2-DEB1C073631F}"/>
-          </ac:picMkLst>
-        </pc:picChg>
-        <pc:picChg chg="mod">
-          <ac:chgData name="Andres Flores" userId="cbb745aa252d2737" providerId="LiveId" clId="{5B02DD72-2521-4955-B22A-9213A9536617}" dt="2026-04-13T19:05:53.487" v="218" actId="571"/>
-          <ac:picMkLst>
-            <pc:docMk/>
-            <pc:sldMk cId="4172594200" sldId="257"/>
-            <ac:picMk id="17" creationId="{67B6E1E2-4372-2B4A-6EF3-972F3E557C7F}"/>
-          </ac:picMkLst>
-        </pc:picChg>
-        <pc:picChg chg="mod">
-          <ac:chgData name="Andres Flores" userId="cbb745aa252d2737" providerId="LiveId" clId="{5B02DD72-2521-4955-B22A-9213A9536617}" dt="2026-04-13T19:31:53.731" v="532"/>
-          <ac:picMkLst>
-            <pc:docMk/>
-            <pc:sldMk cId="4172594200" sldId="257"/>
-            <ac:picMk id="22" creationId="{062D6CEC-5384-00E8-241E-DA02AABD8941}"/>
-          </ac:picMkLst>
-        </pc:picChg>
-        <pc:picChg chg="mod">
-          <ac:chgData name="Andres Flores" userId="cbb745aa252d2737" providerId="LiveId" clId="{5B02DD72-2521-4955-B22A-9213A9536617}" dt="2026-04-13T19:31:53.731" v="532"/>
-          <ac:picMkLst>
-            <pc:docMk/>
-            <pc:sldMk cId="4172594200" sldId="257"/>
-            <ac:picMk id="23" creationId="{A1ADA1E4-D45D-A336-9900-A91565AEBFC8}"/>
-          </ac:picMkLst>
-        </pc:picChg>
-        <pc:picChg chg="mod">
-          <ac:chgData name="Andres Flores" userId="cbb745aa252d2737" providerId="LiveId" clId="{5B02DD72-2521-4955-B22A-9213A9536617}" dt="2026-04-13T19:31:53.731" v="532"/>
-          <ac:picMkLst>
-            <pc:docMk/>
-            <pc:sldMk cId="4172594200" sldId="257"/>
-            <ac:picMk id="24" creationId="{7A7800D6-E583-E689-6D86-DA89F27C2387}"/>
-          </ac:picMkLst>
-        </pc:picChg>
-        <pc:picChg chg="mod">
-          <ac:chgData name="Andres Flores" userId="cbb745aa252d2737" providerId="LiveId" clId="{5B02DD72-2521-4955-B22A-9213A9536617}" dt="2026-04-13T19:31:53.731" v="532"/>
-          <ac:picMkLst>
-            <pc:docMk/>
-            <pc:sldMk cId="4172594200" sldId="257"/>
-            <ac:picMk id="25" creationId="{AB6984C3-0184-5461-762E-591D370A3585}"/>
-          </ac:picMkLst>
-        </pc:picChg>
-        <pc:picChg chg="mod">
-          <ac:chgData name="Andres Flores" userId="cbb745aa252d2737" providerId="LiveId" clId="{5B02DD72-2521-4955-B22A-9213A9536617}" dt="2026-04-13T19:31:53.731" v="532"/>
-          <ac:picMkLst>
-            <pc:docMk/>
-            <pc:sldMk cId="4172594200" sldId="257"/>
-            <ac:picMk id="26" creationId="{D7973B0D-96F0-EBF2-22E9-01892FE6C869}"/>
-          </ac:picMkLst>
-        </pc:picChg>
-        <pc:picChg chg="add del mod topLvl modCrop">
-          <ac:chgData name="Andres Flores" userId="cbb745aa252d2737" providerId="LiveId" clId="{5B02DD72-2521-4955-B22A-9213A9536617}" dt="2026-04-13T19:59:27.089" v="562" actId="478"/>
-          <ac:picMkLst>
-            <pc:docMk/>
-            <pc:sldMk cId="4172594200" sldId="257"/>
-            <ac:picMk id="31" creationId="{29EE6B26-9C22-73C2-4091-D4F0AE23BCA8}"/>
-          </ac:picMkLst>
-        </pc:picChg>
-      </pc:sldChg>
-      <pc:sldChg chg="addSp modSp add del mod">
-        <pc:chgData name="Andres Flores" userId="cbb745aa252d2737" providerId="LiveId" clId="{5B02DD72-2521-4955-B22A-9213A9536617}" dt="2026-04-13T18:58:52.959" v="180" actId="47"/>
-        <pc:sldMkLst>
-          <pc:docMk/>
-          <pc:sldMk cId="4184687551" sldId="257"/>
-        </pc:sldMkLst>
-        <pc:spChg chg="add mod">
-          <ac:chgData name="Andres Flores" userId="cbb745aa252d2737" providerId="LiveId" clId="{5B02DD72-2521-4955-B22A-9213A9536617}" dt="2026-04-13T18:58:27.560" v="178" actId="1582"/>
-          <ac:spMkLst>
-            <pc:docMk/>
-            <pc:sldMk cId="4184687551" sldId="257"/>
-            <ac:spMk id="3" creationId="{74AD3326-DE80-E396-FE0C-E49913CB9362}"/>
-          </ac:spMkLst>
-        </pc:spChg>
-        <pc:spChg chg="add mod">
-          <ac:chgData name="Andres Flores" userId="cbb745aa252d2737" providerId="LiveId" clId="{5B02DD72-2521-4955-B22A-9213A9536617}" dt="2026-04-13T18:58:27.560" v="178" actId="1582"/>
-          <ac:spMkLst>
-            <pc:docMk/>
-            <pc:sldMk cId="4184687551" sldId="257"/>
-            <ac:spMk id="5" creationId="{D63F87CD-0F3E-551C-66C6-79F5DD2245BE}"/>
-          </ac:spMkLst>
-        </pc:spChg>
-        <pc:picChg chg="add mod">
-          <ac:chgData name="Andres Flores" userId="cbb745aa252d2737" providerId="LiveId" clId="{5B02DD72-2521-4955-B22A-9213A9536617}" dt="2026-04-13T18:58:02.902" v="174"/>
-          <ac:picMkLst>
-            <pc:docMk/>
-            <pc:sldMk cId="4184687551" sldId="257"/>
-            <ac:picMk id="2" creationId="{611B2354-774C-8EC1-BD75-652AB118D164}"/>
-          </ac:picMkLst>
-        </pc:picChg>
-        <pc:picChg chg="add mod">
-          <ac:chgData name="Andres Flores" userId="cbb745aa252d2737" providerId="LiveId" clId="{5B02DD72-2521-4955-B22A-9213A9536617}" dt="2026-04-13T18:58:02.902" v="174"/>
-          <ac:picMkLst>
-            <pc:docMk/>
-            <pc:sldMk cId="4184687551" sldId="257"/>
-            <ac:picMk id="4" creationId="{9EDFEC93-90A2-116D-32A9-8C8B46F57B8E}"/>
           </ac:picMkLst>
         </pc:picChg>
       </pc:sldChg>
@@ -881,86 +274,6 @@
             <pc:docMk/>
             <pc:sldMk cId="4013530822" sldId="258"/>
             <ac:spMk id="2" creationId="{2F6735A8-F20E-CDA0-D38A-A472F9B6304C}"/>
-          </ac:spMkLst>
-        </pc:spChg>
-        <pc:spChg chg="mod">
-          <ac:chgData name="Andres Flores" userId="cbb745aa252d2737" providerId="LiveId" clId="{5B02DD72-2521-4955-B22A-9213A9536617}" dt="2026-04-13T22:23:52.343" v="653" actId="571"/>
-          <ac:spMkLst>
-            <pc:docMk/>
-            <pc:sldMk cId="4013530822" sldId="258"/>
-            <ac:spMk id="7" creationId="{117F2F5F-5842-1D60-1D55-C646FE9CC205}"/>
-          </ac:spMkLst>
-        </pc:spChg>
-        <pc:spChg chg="mod">
-          <ac:chgData name="Andres Flores" userId="cbb745aa252d2737" providerId="LiveId" clId="{5B02DD72-2521-4955-B22A-9213A9536617}" dt="2026-04-13T19:13:37.617" v="281"/>
-          <ac:spMkLst>
-            <pc:docMk/>
-            <pc:sldMk cId="4013530822" sldId="258"/>
-            <ac:spMk id="7" creationId="{AA784344-11FA-BBE9-5F3F-1C8C8CA5306A}"/>
-          </ac:spMkLst>
-        </pc:spChg>
-        <pc:spChg chg="mod">
-          <ac:chgData name="Andres Flores" userId="cbb745aa252d2737" providerId="LiveId" clId="{5B02DD72-2521-4955-B22A-9213A9536617}" dt="2026-04-13T19:13:37.617" v="281"/>
-          <ac:spMkLst>
-            <pc:docMk/>
-            <pc:sldMk cId="4013530822" sldId="258"/>
-            <ac:spMk id="9" creationId="{5449D780-3D92-83A8-D156-F910E148FAEA}"/>
-          </ac:spMkLst>
-        </pc:spChg>
-        <pc:spChg chg="mod">
-          <ac:chgData name="Andres Flores" userId="cbb745aa252d2737" providerId="LiveId" clId="{5B02DD72-2521-4955-B22A-9213A9536617}" dt="2026-04-13T19:13:37.617" v="281"/>
-          <ac:spMkLst>
-            <pc:docMk/>
-            <pc:sldMk cId="4013530822" sldId="258"/>
-            <ac:spMk id="11" creationId="{1C66C11F-D7A3-76A1-06A0-501967164401}"/>
-          </ac:spMkLst>
-        </pc:spChg>
-        <pc:spChg chg="mod">
-          <ac:chgData name="Andres Flores" userId="cbb745aa252d2737" providerId="LiveId" clId="{5B02DD72-2521-4955-B22A-9213A9536617}" dt="2026-04-13T22:23:52.343" v="653" actId="571"/>
-          <ac:spMkLst>
-            <pc:docMk/>
-            <pc:sldMk cId="4013530822" sldId="258"/>
-            <ac:spMk id="13" creationId="{2ACE8504-F7FF-0B6C-36FB-71C8F43AA46D}"/>
-          </ac:spMkLst>
-        </pc:spChg>
-        <pc:spChg chg="mod">
-          <ac:chgData name="Andres Flores" userId="cbb745aa252d2737" providerId="LiveId" clId="{5B02DD72-2521-4955-B22A-9213A9536617}" dt="2026-04-13T19:13:37.617" v="281"/>
-          <ac:spMkLst>
-            <pc:docMk/>
-            <pc:sldMk cId="4013530822" sldId="258"/>
-            <ac:spMk id="13" creationId="{BFDC4004-8B4A-7C6F-DA18-04F299871D06}"/>
-          </ac:spMkLst>
-        </pc:spChg>
-        <pc:spChg chg="mod">
-          <ac:chgData name="Andres Flores" userId="cbb745aa252d2737" providerId="LiveId" clId="{5B02DD72-2521-4955-B22A-9213A9536617}" dt="2026-04-13T22:23:52.343" v="653" actId="571"/>
-          <ac:spMkLst>
-            <pc:docMk/>
-            <pc:sldMk cId="4013530822" sldId="258"/>
-            <ac:spMk id="14" creationId="{49C5B86E-EC1D-229A-499E-AB8DCDCE5377}"/>
-          </ac:spMkLst>
-        </pc:spChg>
-        <pc:spChg chg="add del mod">
-          <ac:chgData name="Andres Flores" userId="cbb745aa252d2737" providerId="LiveId" clId="{5B02DD72-2521-4955-B22A-9213A9536617}" dt="2026-04-13T19:13:49.825" v="284" actId="478"/>
-          <ac:spMkLst>
-            <pc:docMk/>
-            <pc:sldMk cId="4013530822" sldId="258"/>
-            <ac:spMk id="14" creationId="{8650780A-9040-17F0-301A-B1D806B650F2}"/>
-          </ac:spMkLst>
-        </pc:spChg>
-        <pc:spChg chg="add del mod ord">
-          <ac:chgData name="Andres Flores" userId="cbb745aa252d2737" providerId="LiveId" clId="{5B02DD72-2521-4955-B22A-9213A9536617}" dt="2026-04-13T19:30:37.901" v="520" actId="478"/>
-          <ac:spMkLst>
-            <pc:docMk/>
-            <pc:sldMk cId="4013530822" sldId="258"/>
-            <ac:spMk id="15" creationId="{54557B41-18F5-B65F-058F-8FFFB969677A}"/>
-          </ac:spMkLst>
-        </pc:spChg>
-        <pc:spChg chg="mod">
-          <ac:chgData name="Andres Flores" userId="cbb745aa252d2737" providerId="LiveId" clId="{5B02DD72-2521-4955-B22A-9213A9536617}" dt="2026-04-13T22:23:52.343" v="653" actId="571"/>
-          <ac:spMkLst>
-            <pc:docMk/>
-            <pc:sldMk cId="4013530822" sldId="258"/>
-            <ac:spMk id="15" creationId="{FEAAD10C-1FAF-1C6E-7477-A0517F96B688}"/>
           </ac:spMkLst>
         </pc:spChg>
         <pc:spChg chg="add del mod ord">
@@ -980,46 +293,6 @@
           </ac:spMkLst>
         </pc:spChg>
         <pc:spChg chg="add mod">
-          <ac:chgData name="Andres Flores" userId="cbb745aa252d2737" providerId="LiveId" clId="{5B02DD72-2521-4955-B22A-9213A9536617}" dt="2026-04-13T19:28:07.215" v="482" actId="208"/>
-          <ac:spMkLst>
-            <pc:docMk/>
-            <pc:sldMk cId="4013530822" sldId="258"/>
-            <ac:spMk id="21" creationId="{7FBBDB6C-D807-EA1C-B641-F22B5A3E95A9}"/>
-          </ac:spMkLst>
-        </pc:spChg>
-        <pc:spChg chg="add mod ord">
-          <ac:chgData name="Andres Flores" userId="cbb745aa252d2737" providerId="LiveId" clId="{5B02DD72-2521-4955-B22A-9213A9536617}" dt="2026-04-13T19:29:24.851" v="500" actId="167"/>
-          <ac:spMkLst>
-            <pc:docMk/>
-            <pc:sldMk cId="4013530822" sldId="258"/>
-            <ac:spMk id="22" creationId="{504C330E-A874-3E6D-B603-E34DAA4ECC7C}"/>
-          </ac:spMkLst>
-        </pc:spChg>
-        <pc:spChg chg="add mod">
-          <ac:chgData name="Andres Flores" userId="cbb745aa252d2737" providerId="LiveId" clId="{5B02DD72-2521-4955-B22A-9213A9536617}" dt="2026-04-13T19:28:44.460" v="487"/>
-          <ac:spMkLst>
-            <pc:docMk/>
-            <pc:sldMk cId="4013530822" sldId="258"/>
-            <ac:spMk id="23" creationId="{0ABD8AC4-4183-3C81-C470-A156F9D62242}"/>
-          </ac:spMkLst>
-        </pc:spChg>
-        <pc:spChg chg="add mod">
-          <ac:chgData name="Andres Flores" userId="cbb745aa252d2737" providerId="LiveId" clId="{5B02DD72-2521-4955-B22A-9213A9536617}" dt="2026-04-13T19:28:44.460" v="487"/>
-          <ac:spMkLst>
-            <pc:docMk/>
-            <pc:sldMk cId="4013530822" sldId="258"/>
-            <ac:spMk id="24" creationId="{18BF2E36-1953-B7D4-C2D5-ACFC6DE09D52}"/>
-          </ac:spMkLst>
-        </pc:spChg>
-        <pc:spChg chg="add del mod">
-          <ac:chgData name="Andres Flores" userId="cbb745aa252d2737" providerId="LiveId" clId="{5B02DD72-2521-4955-B22A-9213A9536617}" dt="2026-04-13T19:31:22.090" v="527" actId="21"/>
-          <ac:spMkLst>
-            <pc:docMk/>
-            <pc:sldMk cId="4013530822" sldId="258"/>
-            <ac:spMk id="25" creationId="{5E9E434F-094D-91DE-AD48-08A2945FCD9A}"/>
-          </ac:spMkLst>
-        </pc:spChg>
-        <pc:spChg chg="add mod">
           <ac:chgData name="Andres Flores" userId="cbb745aa252d2737" providerId="LiveId" clId="{5B02DD72-2521-4955-B22A-9213A9536617}" dt="2026-04-13T19:31:50.566" v="531" actId="164"/>
           <ac:spMkLst>
             <pc:docMk/>
@@ -1027,30 +300,6 @@
             <ac:spMk id="26" creationId="{5E9E434F-094D-91DE-AD48-08A2945FCD9A}"/>
           </ac:spMkLst>
         </pc:spChg>
-        <pc:grpChg chg="add mod">
-          <ac:chgData name="Andres Flores" userId="cbb745aa252d2737" providerId="LiveId" clId="{5B02DD72-2521-4955-B22A-9213A9536617}" dt="2026-04-13T22:23:52.343" v="653" actId="571"/>
-          <ac:grpSpMkLst>
-            <pc:docMk/>
-            <pc:sldMk cId="4013530822" sldId="258"/>
-            <ac:grpSpMk id="6" creationId="{0F7555BC-0EE0-F567-2567-2CB04360269A}"/>
-          </ac:grpSpMkLst>
-        </pc:grpChg>
-        <pc:grpChg chg="add mod">
-          <ac:chgData name="Andres Flores" userId="cbb745aa252d2737" providerId="LiveId" clId="{5B02DD72-2521-4955-B22A-9213A9536617}" dt="2026-04-13T19:13:37.617" v="281"/>
-          <ac:grpSpMkLst>
-            <pc:docMk/>
-            <pc:sldMk cId="4013530822" sldId="258"/>
-            <ac:grpSpMk id="6" creationId="{BD4A295A-C6ED-03C4-3931-E26E47AAD65F}"/>
-          </ac:grpSpMkLst>
-        </pc:grpChg>
-        <pc:grpChg chg="mod">
-          <ac:chgData name="Andres Flores" userId="cbb745aa252d2737" providerId="LiveId" clId="{5B02DD72-2521-4955-B22A-9213A9536617}" dt="2026-04-13T19:13:37.617" v="281"/>
-          <ac:grpSpMkLst>
-            <pc:docMk/>
-            <pc:sldMk cId="4013530822" sldId="258"/>
-            <ac:grpSpMk id="8" creationId="{DAF13CC0-6A66-D631-3A84-88BABA821EFD}"/>
-          </ac:grpSpMkLst>
-        </pc:grpChg>
         <pc:grpChg chg="add mod">
           <ac:chgData name="Andres Flores" userId="cbb745aa252d2737" providerId="LiveId" clId="{5B02DD72-2521-4955-B22A-9213A9536617}" dt="2026-04-13T19:31:50.566" v="531" actId="164"/>
           <ac:grpSpMkLst>
@@ -1083,70 +332,6 @@
             <ac:picMk id="5" creationId="{951BA050-6A0F-6F7C-C766-25EE4C7134E6}"/>
           </ac:picMkLst>
         </pc:picChg>
-        <pc:picChg chg="mod">
-          <ac:chgData name="Andres Flores" userId="cbb745aa252d2737" providerId="LiveId" clId="{5B02DD72-2521-4955-B22A-9213A9536617}" dt="2026-04-13T22:23:52.343" v="653" actId="571"/>
-          <ac:picMkLst>
-            <pc:docMk/>
-            <pc:sldMk cId="4013530822" sldId="258"/>
-            <ac:picMk id="8" creationId="{4B1AFCAB-0622-20C1-6AC0-9FA0960F8952}"/>
-          </ac:picMkLst>
-        </pc:picChg>
-        <pc:picChg chg="mod">
-          <ac:chgData name="Andres Flores" userId="cbb745aa252d2737" providerId="LiveId" clId="{5B02DD72-2521-4955-B22A-9213A9536617}" dt="2026-04-13T22:23:52.343" v="653" actId="571"/>
-          <ac:picMkLst>
-            <pc:docMk/>
-            <pc:sldMk cId="4013530822" sldId="258"/>
-            <ac:picMk id="9" creationId="{6911680F-FA60-37C5-E3FF-F31C30D5F03B}"/>
-          </ac:picMkLst>
-        </pc:picChg>
-        <pc:picChg chg="mod">
-          <ac:chgData name="Andres Flores" userId="cbb745aa252d2737" providerId="LiveId" clId="{5B02DD72-2521-4955-B22A-9213A9536617}" dt="2026-04-13T22:23:52.343" v="653" actId="571"/>
-          <ac:picMkLst>
-            <pc:docMk/>
-            <pc:sldMk cId="4013530822" sldId="258"/>
-            <ac:picMk id="10" creationId="{01764275-5815-623B-738F-4B2F446B1C87}"/>
-          </ac:picMkLst>
-        </pc:picChg>
-        <pc:picChg chg="mod">
-          <ac:chgData name="Andres Flores" userId="cbb745aa252d2737" providerId="LiveId" clId="{5B02DD72-2521-4955-B22A-9213A9536617}" dt="2026-04-13T19:13:37.617" v="281"/>
-          <ac:picMkLst>
-            <pc:docMk/>
-            <pc:sldMk cId="4013530822" sldId="258"/>
-            <ac:picMk id="10" creationId="{71D9CB19-34DC-5278-AD3D-AF0FE82E7DA4}"/>
-          </ac:picMkLst>
-        </pc:picChg>
-        <pc:picChg chg="mod">
-          <ac:chgData name="Andres Flores" userId="cbb745aa252d2737" providerId="LiveId" clId="{5B02DD72-2521-4955-B22A-9213A9536617}" dt="2026-04-13T22:23:52.343" v="653" actId="571"/>
-          <ac:picMkLst>
-            <pc:docMk/>
-            <pc:sldMk cId="4013530822" sldId="258"/>
-            <ac:picMk id="11" creationId="{66B70439-C04B-0469-2C17-34293A2E62A7}"/>
-          </ac:picMkLst>
-        </pc:picChg>
-        <pc:picChg chg="mod">
-          <ac:chgData name="Andres Flores" userId="cbb745aa252d2737" providerId="LiveId" clId="{5B02DD72-2521-4955-B22A-9213A9536617}" dt="2026-04-13T19:13:37.617" v="281"/>
-          <ac:picMkLst>
-            <pc:docMk/>
-            <pc:sldMk cId="4013530822" sldId="258"/>
-            <ac:picMk id="12" creationId="{C4410E32-4C2F-D6EC-45A3-0C68781969EE}"/>
-          </ac:picMkLst>
-        </pc:picChg>
-        <pc:picChg chg="mod">
-          <ac:chgData name="Andres Flores" userId="cbb745aa252d2737" providerId="LiveId" clId="{5B02DD72-2521-4955-B22A-9213A9536617}" dt="2026-04-13T22:23:52.343" v="653" actId="571"/>
-          <ac:picMkLst>
-            <pc:docMk/>
-            <pc:sldMk cId="4013530822" sldId="258"/>
-            <ac:picMk id="12" creationId="{FFEE1C59-6205-2870-6FA0-90AD67BB2968}"/>
-          </ac:picMkLst>
-        </pc:picChg>
-        <pc:picChg chg="add del mod">
-          <ac:chgData name="Andres Flores" userId="cbb745aa252d2737" providerId="LiveId" clId="{5B02DD72-2521-4955-B22A-9213A9536617}" dt="2026-04-13T19:24:45.451" v="441" actId="478"/>
-          <ac:picMkLst>
-            <pc:docMk/>
-            <pc:sldMk cId="4013530822" sldId="258"/>
-            <ac:picMk id="17" creationId="{6F69EAD1-85B3-021F-90E1-6240E1BE11DD}"/>
-          </ac:picMkLst>
-        </pc:picChg>
         <pc:picChg chg="add mod">
           <ac:chgData name="Andres Flores" userId="cbb745aa252d2737" providerId="LiveId" clId="{5B02DD72-2521-4955-B22A-9213A9536617}" dt="2026-04-13T19:58:49.319" v="559" actId="1035"/>
           <ac:picMkLst>
@@ -1171,142 +356,6 @@
           <pc:sldMk cId="234429587" sldId="259"/>
         </pc:sldMkLst>
         <pc:spChg chg="add del mod">
-          <ac:chgData name="Andres Flores" userId="cbb745aa252d2737" providerId="LiveId" clId="{5B02DD72-2521-4955-B22A-9213A9536617}" dt="2026-04-13T19:16:11.629" v="313"/>
-          <ac:spMkLst>
-            <pc:docMk/>
-            <pc:sldMk cId="234429587" sldId="259"/>
-            <ac:spMk id="2" creationId="{6E93C7B3-1570-8BF4-9E6F-E23C5D404C8E}"/>
-          </ac:spMkLst>
-        </pc:spChg>
-        <pc:spChg chg="add del mod">
-          <ac:chgData name="Andres Flores" userId="cbb745aa252d2737" providerId="LiveId" clId="{5B02DD72-2521-4955-B22A-9213A9536617}" dt="2026-04-13T19:15:47.241" v="310" actId="478"/>
-          <ac:spMkLst>
-            <pc:docMk/>
-            <pc:sldMk cId="234429587" sldId="259"/>
-            <ac:spMk id="3" creationId="{2065297E-52BE-DABE-CCEA-6A379019DEF1}"/>
-          </ac:spMkLst>
-        </pc:spChg>
-        <pc:spChg chg="add del mod">
-          <ac:chgData name="Andres Flores" userId="cbb745aa252d2737" providerId="LiveId" clId="{5B02DD72-2521-4955-B22A-9213A9536617}" dt="2026-04-13T19:15:45.622" v="309" actId="21"/>
-          <ac:spMkLst>
-            <pc:docMk/>
-            <pc:sldMk cId="234429587" sldId="259"/>
-            <ac:spMk id="4" creationId="{2B882D40-8A6B-24DA-9286-A91FD8B0121D}"/>
-          </ac:spMkLst>
-        </pc:spChg>
-        <pc:spChg chg="add del mod">
-          <ac:chgData name="Andres Flores" userId="cbb745aa252d2737" providerId="LiveId" clId="{5B02DD72-2521-4955-B22A-9213A9536617}" dt="2026-04-13T19:15:45.622" v="309" actId="21"/>
-          <ac:spMkLst>
-            <pc:docMk/>
-            <pc:sldMk cId="234429587" sldId="259"/>
-            <ac:spMk id="5" creationId="{DD652AFD-2809-4695-1AA6-8178F43A5F92}"/>
-          </ac:spMkLst>
-        </pc:spChg>
-        <pc:spChg chg="add del mod">
-          <ac:chgData name="Andres Flores" userId="cbb745aa252d2737" providerId="LiveId" clId="{5B02DD72-2521-4955-B22A-9213A9536617}" dt="2026-04-13T19:16:11.629" v="313"/>
-          <ac:spMkLst>
-            <pc:docMk/>
-            <pc:sldMk cId="234429587" sldId="259"/>
-            <ac:spMk id="6" creationId="{2B882D40-8A6B-24DA-9286-A91FD8B0121D}"/>
-          </ac:spMkLst>
-        </pc:spChg>
-        <pc:spChg chg="add del mod">
-          <ac:chgData name="Andres Flores" userId="cbb745aa252d2737" providerId="LiveId" clId="{5B02DD72-2521-4955-B22A-9213A9536617}" dt="2026-04-13T19:16:11.629" v="313"/>
-          <ac:spMkLst>
-            <pc:docMk/>
-            <pc:sldMk cId="234429587" sldId="259"/>
-            <ac:spMk id="7" creationId="{DD652AFD-2809-4695-1AA6-8178F43A5F92}"/>
-          </ac:spMkLst>
-        </pc:spChg>
-        <pc:spChg chg="del mod">
-          <ac:chgData name="Andres Flores" userId="cbb745aa252d2737" providerId="LiveId" clId="{5B02DD72-2521-4955-B22A-9213A9536617}" dt="2026-04-13T19:26:13.739" v="458" actId="478"/>
-          <ac:spMkLst>
-            <pc:docMk/>
-            <pc:sldMk cId="234429587" sldId="259"/>
-            <ac:spMk id="8" creationId="{B2F0E298-437E-EEA3-59C7-0F67D641D271}"/>
-          </ac:spMkLst>
-        </pc:spChg>
-        <pc:spChg chg="add del mod topLvl">
-          <ac:chgData name="Andres Flores" userId="cbb745aa252d2737" providerId="LiveId" clId="{5B02DD72-2521-4955-B22A-9213A9536617}" dt="2026-04-13T19:30:06.885" v="512" actId="21"/>
-          <ac:spMkLst>
-            <pc:docMk/>
-            <pc:sldMk cId="234429587" sldId="259"/>
-            <ac:spMk id="10" creationId="{6BF1B3AB-29CC-A416-D464-7657F8220A1D}"/>
-          </ac:spMkLst>
-        </pc:spChg>
-        <pc:spChg chg="add del mod topLvl">
-          <ac:chgData name="Andres Flores" userId="cbb745aa252d2737" providerId="LiveId" clId="{5B02DD72-2521-4955-B22A-9213A9536617}" dt="2026-04-13T19:30:08.177" v="513" actId="478"/>
-          <ac:spMkLst>
-            <pc:docMk/>
-            <pc:sldMk cId="234429587" sldId="259"/>
-            <ac:spMk id="12" creationId="{BFB0B47B-7B05-805B-FE4A-5D1DDE6AE301}"/>
-          </ac:spMkLst>
-        </pc:spChg>
-        <pc:spChg chg="del mod topLvl">
-          <ac:chgData name="Andres Flores" userId="cbb745aa252d2737" providerId="LiveId" clId="{5B02DD72-2521-4955-B22A-9213A9536617}" dt="2026-04-13T19:26:35.246" v="464" actId="478"/>
-          <ac:spMkLst>
-            <pc:docMk/>
-            <pc:sldMk cId="234429587" sldId="259"/>
-            <ac:spMk id="14" creationId="{E80330B2-BCBC-C8EE-2326-004381BA7448}"/>
-          </ac:spMkLst>
-        </pc:spChg>
-        <pc:spChg chg="del mod topLvl">
-          <ac:chgData name="Andres Flores" userId="cbb745aa252d2737" providerId="LiveId" clId="{5B02DD72-2521-4955-B22A-9213A9536617}" dt="2026-04-13T19:26:37.156" v="465" actId="478"/>
-          <ac:spMkLst>
-            <pc:docMk/>
-            <pc:sldMk cId="234429587" sldId="259"/>
-            <ac:spMk id="16" creationId="{87897016-2F00-18F8-AE66-D3613ACA63A7}"/>
-          </ac:spMkLst>
-        </pc:spChg>
-        <pc:spChg chg="mod">
-          <ac:chgData name="Andres Flores" userId="cbb745aa252d2737" providerId="LiveId" clId="{5B02DD72-2521-4955-B22A-9213A9536617}" dt="2026-04-13T19:29:27.954" v="502"/>
-          <ac:spMkLst>
-            <pc:docMk/>
-            <pc:sldMk cId="234429587" sldId="259"/>
-            <ac:spMk id="17" creationId="{E95A5562-D771-078E-D159-8A74E6203A75}"/>
-          </ac:spMkLst>
-        </pc:spChg>
-        <pc:spChg chg="add del mod">
-          <ac:chgData name="Andres Flores" userId="cbb745aa252d2737" providerId="LiveId" clId="{5B02DD72-2521-4955-B22A-9213A9536617}" dt="2026-04-13T19:30:06.885" v="512" actId="21"/>
-          <ac:spMkLst>
-            <pc:docMk/>
-            <pc:sldMk cId="234429587" sldId="259"/>
-            <ac:spMk id="18" creationId="{6C830EA6-4725-6391-BA3E-A89F24CDC864}"/>
-          </ac:spMkLst>
-        </pc:spChg>
-        <pc:spChg chg="add del mod">
-          <ac:chgData name="Andres Flores" userId="cbb745aa252d2737" providerId="LiveId" clId="{5B02DD72-2521-4955-B22A-9213A9536617}" dt="2026-04-13T19:30:06.885" v="512" actId="21"/>
-          <ac:spMkLst>
-            <pc:docMk/>
-            <pc:sldMk cId="234429587" sldId="259"/>
-            <ac:spMk id="19" creationId="{D19B00D1-C749-CF9B-877C-6EC8AC5DF23C}"/>
-          </ac:spMkLst>
-        </pc:spChg>
-        <pc:spChg chg="add del mod">
-          <ac:chgData name="Andres Flores" userId="cbb745aa252d2737" providerId="LiveId" clId="{5B02DD72-2521-4955-B22A-9213A9536617}" dt="2026-04-13T19:30:31.412" v="517"/>
-          <ac:spMkLst>
-            <pc:docMk/>
-            <pc:sldMk cId="234429587" sldId="259"/>
-            <ac:spMk id="20" creationId="{6BF1B3AB-29CC-A416-D464-7657F8220A1D}"/>
-          </ac:spMkLst>
-        </pc:spChg>
-        <pc:spChg chg="add del mod">
-          <ac:chgData name="Andres Flores" userId="cbb745aa252d2737" providerId="LiveId" clId="{5B02DD72-2521-4955-B22A-9213A9536617}" dt="2026-04-13T19:30:31.412" v="517"/>
-          <ac:spMkLst>
-            <pc:docMk/>
-            <pc:sldMk cId="234429587" sldId="259"/>
-            <ac:spMk id="21" creationId="{6C830EA6-4725-6391-BA3E-A89F24CDC864}"/>
-          </ac:spMkLst>
-        </pc:spChg>
-        <pc:spChg chg="add del mod">
-          <ac:chgData name="Andres Flores" userId="cbb745aa252d2737" providerId="LiveId" clId="{5B02DD72-2521-4955-B22A-9213A9536617}" dt="2026-04-13T19:30:31.412" v="517"/>
-          <ac:spMkLst>
-            <pc:docMk/>
-            <pc:sldMk cId="234429587" sldId="259"/>
-            <ac:spMk id="22" creationId="{D19B00D1-C749-CF9B-877C-6EC8AC5DF23C}"/>
-          </ac:spMkLst>
-        </pc:spChg>
-        <pc:spChg chg="add del mod">
           <ac:chgData name="Andres Flores" userId="cbb745aa252d2737" providerId="LiveId" clId="{5B02DD72-2521-4955-B22A-9213A9536617}" dt="2026-04-13T19:30:34.883" v="519" actId="21"/>
           <ac:spMkLst>
             <pc:docMk/>
@@ -1314,95 +363,15 @@
             <ac:spMk id="23" creationId="{92CB803C-D1DD-61CD-1983-BCB7C99F11BD}"/>
           </ac:spMkLst>
         </pc:spChg>
-        <pc:grpChg chg="add del mod">
-          <ac:chgData name="Andres Flores" userId="cbb745aa252d2737" providerId="LiveId" clId="{5B02DD72-2521-4955-B22A-9213A9536617}" dt="2026-04-13T19:26:24.855" v="460" actId="165"/>
-          <ac:grpSpMkLst>
-            <pc:docMk/>
-            <pc:sldMk cId="234429587" sldId="259"/>
-            <ac:grpSpMk id="9" creationId="{D721B532-1A13-269A-281D-F7B84200837C}"/>
-          </ac:grpSpMkLst>
-        </pc:grpChg>
-        <pc:grpChg chg="add del mod topLvl">
-          <ac:chgData name="Andres Flores" userId="cbb745aa252d2737" providerId="LiveId" clId="{5B02DD72-2521-4955-B22A-9213A9536617}" dt="2026-04-13T19:26:32.543" v="463" actId="165"/>
-          <ac:grpSpMkLst>
-            <pc:docMk/>
-            <pc:sldMk cId="234429587" sldId="259"/>
-            <ac:grpSpMk id="11" creationId="{3B738E97-1440-49F9-00EB-0A1CA34D37E7}"/>
-          </ac:grpSpMkLst>
-        </pc:grpChg>
-        <pc:picChg chg="del mod topLvl">
-          <ac:chgData name="Andres Flores" userId="cbb745aa252d2737" providerId="LiveId" clId="{5B02DD72-2521-4955-B22A-9213A9536617}" dt="2026-04-13T19:26:41.420" v="467" actId="478"/>
-          <ac:picMkLst>
-            <pc:docMk/>
-            <pc:sldMk cId="234429587" sldId="259"/>
-            <ac:picMk id="13" creationId="{5C2FFC1E-FF71-CAEE-DDFE-BEB175073BF4}"/>
-          </ac:picMkLst>
-        </pc:picChg>
-        <pc:picChg chg="del mod topLvl">
-          <ac:chgData name="Andres Flores" userId="cbb745aa252d2737" providerId="LiveId" clId="{5B02DD72-2521-4955-B22A-9213A9536617}" dt="2026-04-13T19:26:39.237" v="466" actId="478"/>
-          <ac:picMkLst>
-            <pc:docMk/>
-            <pc:sldMk cId="234429587" sldId="259"/>
-            <ac:picMk id="15" creationId="{E9B65A92-E8AF-3D62-90BA-8DF7B3A60B65}"/>
-          </ac:picMkLst>
-        </pc:picChg>
       </pc:sldChg>
       <pc:sldChg chg="addSp delSp modSp new mod">
-        <pc:chgData name="Andres Flores" userId="cbb745aa252d2737" providerId="LiveId" clId="{5B02DD72-2521-4955-B22A-9213A9536617}" dt="2026-04-13T22:23:28.772" v="651"/>
+        <pc:chgData name="Andres Flores" userId="cbb745aa252d2737" providerId="LiveId" clId="{5B02DD72-2521-4955-B22A-9213A9536617}" dt="2026-04-25T05:55:02.995" v="737" actId="1076"/>
         <pc:sldMkLst>
           <pc:docMk/>
           <pc:sldMk cId="3627814364" sldId="260"/>
         </pc:sldMkLst>
         <pc:spChg chg="mod">
-          <ac:chgData name="Andres Flores" userId="cbb745aa252d2737" providerId="LiveId" clId="{5B02DD72-2521-4955-B22A-9213A9536617}" dt="2026-04-13T20:12:52.117" v="586"/>
-          <ac:spMkLst>
-            <pc:docMk/>
-            <pc:sldMk cId="3627814364" sldId="260"/>
-            <ac:spMk id="3" creationId="{D4D371C1-C94F-2FF5-279F-E1C99CFA16F6}"/>
-          </ac:spMkLst>
-        </pc:spChg>
-        <pc:spChg chg="mod">
-          <ac:chgData name="Andres Flores" userId="cbb745aa252d2737" providerId="LiveId" clId="{5B02DD72-2521-4955-B22A-9213A9536617}" dt="2026-04-13T20:12:52.117" v="586"/>
-          <ac:spMkLst>
-            <pc:docMk/>
-            <pc:sldMk cId="3627814364" sldId="260"/>
-            <ac:spMk id="4" creationId="{119C131E-E79B-43BF-1B2D-4B306C28D319}"/>
-          </ac:spMkLst>
-        </pc:spChg>
-        <pc:spChg chg="mod">
-          <ac:chgData name="Andres Flores" userId="cbb745aa252d2737" providerId="LiveId" clId="{5B02DD72-2521-4955-B22A-9213A9536617}" dt="2026-04-13T22:23:16.672" v="642"/>
-          <ac:spMkLst>
-            <pc:docMk/>
-            <pc:sldMk cId="3627814364" sldId="260"/>
-            <ac:spMk id="5" creationId="{810DA856-1780-5D95-B468-472E69C70019}"/>
-          </ac:spMkLst>
-        </pc:spChg>
-        <pc:spChg chg="mod">
-          <ac:chgData name="Andres Flores" userId="cbb745aa252d2737" providerId="LiveId" clId="{5B02DD72-2521-4955-B22A-9213A9536617}" dt="2026-04-13T22:23:16.672" v="642"/>
-          <ac:spMkLst>
-            <pc:docMk/>
-            <pc:sldMk cId="3627814364" sldId="260"/>
-            <ac:spMk id="6" creationId="{0E1CA56F-2869-C8E6-3A70-7FF4C74B98DB}"/>
-          </ac:spMkLst>
-        </pc:spChg>
-        <pc:spChg chg="mod">
-          <ac:chgData name="Andres Flores" userId="cbb745aa252d2737" providerId="LiveId" clId="{5B02DD72-2521-4955-B22A-9213A9536617}" dt="2026-04-13T20:13:08.625" v="590"/>
-          <ac:spMkLst>
-            <pc:docMk/>
-            <pc:sldMk cId="3627814364" sldId="260"/>
-            <ac:spMk id="7" creationId="{8A72454B-5D5D-2970-823E-2A91834E06B4}"/>
-          </ac:spMkLst>
-        </pc:spChg>
-        <pc:spChg chg="mod">
-          <ac:chgData name="Andres Flores" userId="cbb745aa252d2737" providerId="LiveId" clId="{5B02DD72-2521-4955-B22A-9213A9536617}" dt="2026-04-13T20:13:08.625" v="590"/>
-          <ac:spMkLst>
-            <pc:docMk/>
-            <pc:sldMk cId="3627814364" sldId="260"/>
-            <ac:spMk id="8" creationId="{C8DB9749-D2E4-3BD9-CC9F-1C438B8CB052}"/>
-          </ac:spMkLst>
-        </pc:spChg>
-        <pc:spChg chg="mod">
-          <ac:chgData name="Andres Flores" userId="cbb745aa252d2737" providerId="LiveId" clId="{5B02DD72-2521-4955-B22A-9213A9536617}" dt="2026-04-13T22:23:28.772" v="651"/>
+          <ac:chgData name="Andres Flores" userId="cbb745aa252d2737" providerId="LiveId" clId="{5B02DD72-2521-4955-B22A-9213A9536617}" dt="2026-04-25T05:54:10.135" v="731" actId="207"/>
           <ac:spMkLst>
             <pc:docMk/>
             <pc:sldMk cId="3627814364" sldId="260"/>
@@ -1410,45 +379,13 @@
           </ac:spMkLst>
         </pc:spChg>
         <pc:spChg chg="mod">
-          <ac:chgData name="Andres Flores" userId="cbb745aa252d2737" providerId="LiveId" clId="{5B02DD72-2521-4955-B22A-9213A9536617}" dt="2026-04-13T22:23:28.772" v="651"/>
+          <ac:chgData name="Andres Flores" userId="cbb745aa252d2737" providerId="LiveId" clId="{5B02DD72-2521-4955-B22A-9213A9536617}" dt="2026-04-25T05:55:02.995" v="737" actId="1076"/>
           <ac:spMkLst>
             <pc:docMk/>
             <pc:sldMk cId="3627814364" sldId="260"/>
             <ac:spMk id="14" creationId="{263E0DA1-4175-E46F-0CA8-02944081E5D6}"/>
           </ac:spMkLst>
         </pc:spChg>
-        <pc:grpChg chg="add mod">
-          <ac:chgData name="Andres Flores" userId="cbb745aa252d2737" providerId="LiveId" clId="{5B02DD72-2521-4955-B22A-9213A9536617}" dt="2026-04-13T22:23:16.672" v="642"/>
-          <ac:grpSpMkLst>
-            <pc:docMk/>
-            <pc:sldMk cId="3627814364" sldId="260"/>
-            <ac:grpSpMk id="2" creationId="{499A6E4C-454E-9EBA-5640-F41761DEB8BD}"/>
-          </ac:grpSpMkLst>
-        </pc:grpChg>
-        <pc:grpChg chg="add del mod">
-          <ac:chgData name="Andres Flores" userId="cbb745aa252d2737" providerId="LiveId" clId="{5B02DD72-2521-4955-B22A-9213A9536617}" dt="2026-04-13T20:13:08.115" v="589" actId="478"/>
-          <ac:grpSpMkLst>
-            <pc:docMk/>
-            <pc:sldMk cId="3627814364" sldId="260"/>
-            <ac:grpSpMk id="2" creationId="{961F89F0-B2AE-3F51-D34A-87EE7332382F}"/>
-          </ac:grpSpMkLst>
-        </pc:grpChg>
-        <pc:grpChg chg="mod">
-          <ac:chgData name="Andres Flores" userId="cbb745aa252d2737" providerId="LiveId" clId="{5B02DD72-2521-4955-B22A-9213A9536617}" dt="2026-04-13T22:23:16.672" v="642"/>
-          <ac:grpSpMkLst>
-            <pc:docMk/>
-            <pc:sldMk cId="3627814364" sldId="260"/>
-            <ac:grpSpMk id="3" creationId="{CB10FDB6-E71C-7F65-1097-B4B2AEF3FFE3}"/>
-          </ac:grpSpMkLst>
-        </pc:grpChg>
-        <pc:grpChg chg="add mod">
-          <ac:chgData name="Andres Flores" userId="cbb745aa252d2737" providerId="LiveId" clId="{5B02DD72-2521-4955-B22A-9213A9536617}" dt="2026-04-13T20:13:08.625" v="590"/>
-          <ac:grpSpMkLst>
-            <pc:docMk/>
-            <pc:sldMk cId="3627814364" sldId="260"/>
-            <ac:grpSpMk id="6" creationId="{8B0CA231-4D39-7F79-1EDF-561AFCFB8A3B}"/>
-          </ac:grpSpMkLst>
-        </pc:grpChg>
         <pc:grpChg chg="add mod">
           <ac:chgData name="Andres Flores" userId="cbb745aa252d2737" providerId="LiveId" clId="{5B02DD72-2521-4955-B22A-9213A9536617}" dt="2026-04-13T22:23:28.772" v="651"/>
           <ac:grpSpMkLst>
@@ -1465,48 +402,8 @@
             <ac:grpSpMk id="10" creationId="{6C584804-52D2-6F49-B192-67C17A919566}"/>
           </ac:grpSpMkLst>
         </pc:grpChg>
-        <pc:picChg chg="mod">
-          <ac:chgData name="Andres Flores" userId="cbb745aa252d2737" providerId="LiveId" clId="{5B02DD72-2521-4955-B22A-9213A9536617}" dt="2026-04-13T22:23:16.672" v="642"/>
-          <ac:picMkLst>
-            <pc:docMk/>
-            <pc:sldMk cId="3627814364" sldId="260"/>
-            <ac:picMk id="4" creationId="{03319BEF-FBAA-8070-3A2B-5488E280F802}"/>
-          </ac:picMkLst>
-        </pc:picChg>
-        <pc:picChg chg="mod">
-          <ac:chgData name="Andres Flores" userId="cbb745aa252d2737" providerId="LiveId" clId="{5B02DD72-2521-4955-B22A-9213A9536617}" dt="2026-04-13T20:12:52.117" v="586"/>
-          <ac:picMkLst>
-            <pc:docMk/>
-            <pc:sldMk cId="3627814364" sldId="260"/>
-            <ac:picMk id="5" creationId="{1FD54B2C-47A5-971E-613E-8D67F59E8C59}"/>
-          </ac:picMkLst>
-        </pc:picChg>
-        <pc:picChg chg="add del mod">
-          <ac:chgData name="Andres Flores" userId="cbb745aa252d2737" providerId="LiveId" clId="{5B02DD72-2521-4955-B22A-9213A9536617}" dt="2026-04-13T22:23:27.722" v="650" actId="22"/>
-          <ac:picMkLst>
-            <pc:docMk/>
-            <pc:sldMk cId="3627814364" sldId="260"/>
-            <ac:picMk id="8" creationId="{22B61A2F-5204-574F-B162-787437E819C1}"/>
-          </ac:picMkLst>
-        </pc:picChg>
-        <pc:picChg chg="mod">
-          <ac:chgData name="Andres Flores" userId="cbb745aa252d2737" providerId="LiveId" clId="{5B02DD72-2521-4955-B22A-9213A9536617}" dt="2026-04-13T20:13:08.625" v="590"/>
-          <ac:picMkLst>
-            <pc:docMk/>
-            <pc:sldMk cId="3627814364" sldId="260"/>
-            <ac:picMk id="9" creationId="{B1D3FE84-3A7E-BEB0-10EF-326B48E933EF}"/>
-          </ac:picMkLst>
-        </pc:picChg>
-        <pc:picChg chg="add del mod modCrop">
-          <ac:chgData name="Andres Flores" userId="cbb745aa252d2737" providerId="LiveId" clId="{5B02DD72-2521-4955-B22A-9213A9536617}" dt="2026-04-13T22:23:16.348" v="641" actId="478"/>
-          <ac:picMkLst>
-            <pc:docMk/>
-            <pc:sldMk cId="3627814364" sldId="260"/>
-            <ac:picMk id="11" creationId="{0A046103-09B0-B78F-B689-BD3DA761168D}"/>
-          </ac:picMkLst>
-        </pc:picChg>
-        <pc:picChg chg="mod">
-          <ac:chgData name="Andres Flores" userId="cbb745aa252d2737" providerId="LiveId" clId="{5B02DD72-2521-4955-B22A-9213A9536617}" dt="2026-04-13T22:23:28.772" v="651"/>
+        <pc:picChg chg="mod modCrop">
+          <ac:chgData name="Andres Flores" userId="cbb745aa252d2737" providerId="LiveId" clId="{5B02DD72-2521-4955-B22A-9213A9536617}" dt="2026-04-25T05:54:47.555" v="736" actId="732"/>
           <ac:picMkLst>
             <pc:docMk/>
             <pc:sldMk cId="3627814364" sldId="260"/>
@@ -1520,94 +417,6 @@
           <pc:docMk/>
           <pc:sldMk cId="3453658217" sldId="261"/>
         </pc:sldMkLst>
-        <pc:spChg chg="mod">
-          <ac:chgData name="Andres Flores" userId="cbb745aa252d2737" providerId="LiveId" clId="{5B02DD72-2521-4955-B22A-9213A9536617}" dt="2026-04-13T20:15:04.437" v="600"/>
-          <ac:spMkLst>
-            <pc:docMk/>
-            <pc:sldMk cId="3453658217" sldId="261"/>
-            <ac:spMk id="3" creationId="{544140A8-2EA0-D509-1803-5B985EFC37B0}"/>
-          </ac:spMkLst>
-        </pc:spChg>
-        <pc:spChg chg="mod">
-          <ac:chgData name="Andres Flores" userId="cbb745aa252d2737" providerId="LiveId" clId="{5B02DD72-2521-4955-B22A-9213A9536617}" dt="2026-04-13T20:15:04.437" v="600"/>
-          <ac:spMkLst>
-            <pc:docMk/>
-            <pc:sldMk cId="3453658217" sldId="261"/>
-            <ac:spMk id="9" creationId="{87C2E4F6-6233-643F-0FBF-12EE36117800}"/>
-          </ac:spMkLst>
-        </pc:spChg>
-        <pc:spChg chg="mod">
-          <ac:chgData name="Andres Flores" userId="cbb745aa252d2737" providerId="LiveId" clId="{5B02DD72-2521-4955-B22A-9213A9536617}" dt="2026-04-13T20:15:04.437" v="600"/>
-          <ac:spMkLst>
-            <pc:docMk/>
-            <pc:sldMk cId="3453658217" sldId="261"/>
-            <ac:spMk id="10" creationId="{37E333B3-F43D-86A1-C69E-35D043DDCDFE}"/>
-          </ac:spMkLst>
-        </pc:spChg>
-        <pc:spChg chg="mod">
-          <ac:chgData name="Andres Flores" userId="cbb745aa252d2737" providerId="LiveId" clId="{5B02DD72-2521-4955-B22A-9213A9536617}" dt="2026-04-13T20:15:04.437" v="600"/>
-          <ac:spMkLst>
-            <pc:docMk/>
-            <pc:sldMk cId="3453658217" sldId="261"/>
-            <ac:spMk id="11" creationId="{47BFB79D-F288-D847-3EF2-A08A88581A93}"/>
-          </ac:spMkLst>
-        </pc:spChg>
-        <pc:spChg chg="add del mod">
-          <ac:chgData name="Andres Flores" userId="cbb745aa252d2737" providerId="LiveId" clId="{5B02DD72-2521-4955-B22A-9213A9536617}" dt="2026-04-13T20:15:50.644" v="623" actId="478"/>
-          <ac:spMkLst>
-            <pc:docMk/>
-            <pc:sldMk cId="3453658217" sldId="261"/>
-            <ac:spMk id="14" creationId="{9D2F297A-AAD8-02A5-7897-C001DE3B5332}"/>
-          </ac:spMkLst>
-        </pc:spChg>
-        <pc:grpChg chg="add mod">
-          <ac:chgData name="Andres Flores" userId="cbb745aa252d2737" providerId="LiveId" clId="{5B02DD72-2521-4955-B22A-9213A9536617}" dt="2026-04-13T20:15:04.437" v="600"/>
-          <ac:grpSpMkLst>
-            <pc:docMk/>
-            <pc:sldMk cId="3453658217" sldId="261"/>
-            <ac:grpSpMk id="2" creationId="{BB0FD574-D6F3-BAA4-1EC5-B8EFBDF7F4B6}"/>
-          </ac:grpSpMkLst>
-        </pc:grpChg>
-        <pc:picChg chg="mod">
-          <ac:chgData name="Andres Flores" userId="cbb745aa252d2737" providerId="LiveId" clId="{5B02DD72-2521-4955-B22A-9213A9536617}" dt="2026-04-13T20:15:04.437" v="600"/>
-          <ac:picMkLst>
-            <pc:docMk/>
-            <pc:sldMk cId="3453658217" sldId="261"/>
-            <ac:picMk id="4" creationId="{30977123-69CD-1EDF-D291-18FD4E8094EA}"/>
-          </ac:picMkLst>
-        </pc:picChg>
-        <pc:picChg chg="mod">
-          <ac:chgData name="Andres Flores" userId="cbb745aa252d2737" providerId="LiveId" clId="{5B02DD72-2521-4955-B22A-9213A9536617}" dt="2026-04-13T20:15:04.437" v="600"/>
-          <ac:picMkLst>
-            <pc:docMk/>
-            <pc:sldMk cId="3453658217" sldId="261"/>
-            <ac:picMk id="5" creationId="{89237971-AFD1-186B-A8D3-D3FBCD9F08EB}"/>
-          </ac:picMkLst>
-        </pc:picChg>
-        <pc:picChg chg="mod">
-          <ac:chgData name="Andres Flores" userId="cbb745aa252d2737" providerId="LiveId" clId="{5B02DD72-2521-4955-B22A-9213A9536617}" dt="2026-04-13T20:15:04.437" v="600"/>
-          <ac:picMkLst>
-            <pc:docMk/>
-            <pc:sldMk cId="3453658217" sldId="261"/>
-            <ac:picMk id="6" creationId="{879CB2D3-C10B-46A3-2B56-CD8A39C9B56C}"/>
-          </ac:picMkLst>
-        </pc:picChg>
-        <pc:picChg chg="mod">
-          <ac:chgData name="Andres Flores" userId="cbb745aa252d2737" providerId="LiveId" clId="{5B02DD72-2521-4955-B22A-9213A9536617}" dt="2026-04-13T20:15:04.437" v="600"/>
-          <ac:picMkLst>
-            <pc:docMk/>
-            <pc:sldMk cId="3453658217" sldId="261"/>
-            <ac:picMk id="7" creationId="{8B0D358E-E0BD-682C-ADBA-26BAF487ADFD}"/>
-          </ac:picMkLst>
-        </pc:picChg>
-        <pc:picChg chg="mod">
-          <ac:chgData name="Andres Flores" userId="cbb745aa252d2737" providerId="LiveId" clId="{5B02DD72-2521-4955-B22A-9213A9536617}" dt="2026-04-13T20:15:04.437" v="600"/>
-          <ac:picMkLst>
-            <pc:docMk/>
-            <pc:sldMk cId="3453658217" sldId="261"/>
-            <ac:picMk id="8" creationId="{A889D3CF-EB19-BEA3-347B-2135CF1F8C74}"/>
-          </ac:picMkLst>
-        </pc:picChg>
         <pc:picChg chg="add mod modCrop">
           <ac:chgData name="Andres Flores" userId="cbb745aa252d2737" providerId="LiveId" clId="{5B02DD72-2521-4955-B22A-9213A9536617}" dt="2026-04-13T22:22:01.156" v="630" actId="1076"/>
           <ac:picMkLst>
@@ -1639,36 +448,12 @@
             <ac:spMk id="4" creationId="{3B5EB4F8-A97E-06AC-72FA-4E8707752D6C}"/>
           </ac:spMkLst>
         </pc:spChg>
-        <pc:spChg chg="mod">
-          <ac:chgData name="Andres Flores" userId="cbb745aa252d2737" providerId="LiveId" clId="{5B02DD72-2521-4955-B22A-9213A9536617}" dt="2026-04-13T22:53:53.746" v="720"/>
-          <ac:spMkLst>
-            <pc:docMk/>
-            <pc:sldMk cId="3125139032" sldId="262"/>
-            <ac:spMk id="11" creationId="{31BDBF81-9ACA-491F-D186-BBA1CDAA9051}"/>
-          </ac:spMkLst>
-        </pc:spChg>
-        <pc:spChg chg="mod">
-          <ac:chgData name="Andres Flores" userId="cbb745aa252d2737" providerId="LiveId" clId="{5B02DD72-2521-4955-B22A-9213A9536617}" dt="2026-04-13T22:53:53.746" v="720"/>
-          <ac:spMkLst>
-            <pc:docMk/>
-            <pc:sldMk cId="3125139032" sldId="262"/>
-            <ac:spMk id="12" creationId="{3CA1E91D-84B5-64A7-F7C5-C78E24166525}"/>
-          </ac:spMkLst>
-        </pc:spChg>
         <pc:grpChg chg="add mod">
           <ac:chgData name="Andres Flores" userId="cbb745aa252d2737" providerId="LiveId" clId="{5B02DD72-2521-4955-B22A-9213A9536617}" dt="2026-04-13T22:53:50.386" v="719" actId="164"/>
           <ac:grpSpMkLst>
             <pc:docMk/>
             <pc:sldMk cId="3125139032" sldId="262"/>
             <ac:grpSpMk id="8" creationId="{F0B81AFC-6F34-08E9-C589-8B63063BB69E}"/>
-          </ac:grpSpMkLst>
-        </pc:grpChg>
-        <pc:grpChg chg="add mod">
-          <ac:chgData name="Andres Flores" userId="cbb745aa252d2737" providerId="LiveId" clId="{5B02DD72-2521-4955-B22A-9213A9536617}" dt="2026-04-13T22:53:53.746" v="720"/>
-          <ac:grpSpMkLst>
-            <pc:docMk/>
-            <pc:sldMk cId="3125139032" sldId="262"/>
-            <ac:grpSpMk id="9" creationId="{30B43504-4C9F-90BB-B89F-483ED60FDDEF}"/>
           </ac:grpSpMkLst>
         </pc:grpChg>
         <pc:picChg chg="add mod">
@@ -1679,36 +464,12 @@
             <ac:picMk id="2" creationId="{79A5558B-D791-9B2B-913B-274A33730B28}"/>
           </ac:picMkLst>
         </pc:picChg>
-        <pc:picChg chg="mod">
-          <ac:chgData name="Andres Flores" userId="cbb745aa252d2737" providerId="LiveId" clId="{5B02DD72-2521-4955-B22A-9213A9536617}" dt="2026-04-13T22:53:53.746" v="720"/>
-          <ac:picMkLst>
-            <pc:docMk/>
-            <pc:sldMk cId="3125139032" sldId="262"/>
-            <ac:picMk id="10" creationId="{7527911A-6853-7219-0860-38B93BB4DDA7}"/>
-          </ac:picMkLst>
-        </pc:picChg>
-        <pc:picChg chg="add del">
-          <ac:chgData name="Andres Flores" userId="cbb745aa252d2737" providerId="LiveId" clId="{5B02DD72-2521-4955-B22A-9213A9536617}" dt="2026-04-13T22:53:56.705" v="722" actId="21"/>
-          <ac:picMkLst>
-            <pc:docMk/>
-            <pc:sldMk cId="3125139032" sldId="262"/>
-            <ac:picMk id="15" creationId="{1B6D948C-3779-617C-AA24-EA25370A8C1E}"/>
-          </ac:picMkLst>
-        </pc:picChg>
         <pc:cxnChg chg="add mod">
           <ac:chgData name="Andres Flores" userId="cbb745aa252d2737" providerId="LiveId" clId="{5B02DD72-2521-4955-B22A-9213A9536617}" dt="2026-04-13T22:53:50.386" v="719" actId="164"/>
           <ac:cxnSpMkLst>
             <pc:docMk/>
             <pc:sldMk cId="3125139032" sldId="262"/>
             <ac:cxnSpMk id="6" creationId="{3CEEC4AD-7B3C-D831-B140-A7B1B36C50DF}"/>
-          </ac:cxnSpMkLst>
-        </pc:cxnChg>
-        <pc:cxnChg chg="mod">
-          <ac:chgData name="Andres Flores" userId="cbb745aa252d2737" providerId="LiveId" clId="{5B02DD72-2521-4955-B22A-9213A9536617}" dt="2026-04-13T22:53:53.746" v="720"/>
-          <ac:cxnSpMkLst>
-            <pc:docMk/>
-            <pc:sldMk cId="3125139032" sldId="262"/>
-            <ac:cxnSpMk id="13" creationId="{4CD6B18A-18C1-4D6B-47AF-32DC5D352EC8}"/>
           </ac:cxnSpMkLst>
         </pc:cxnChg>
       </pc:sldChg>
@@ -1718,28 +479,12 @@
           <pc:docMk/>
           <pc:sldMk cId="4119995374" sldId="263"/>
         </pc:sldMkLst>
-        <pc:spChg chg="add del mod">
-          <ac:chgData name="Andres Flores" userId="cbb745aa252d2737" providerId="LiveId" clId="{5B02DD72-2521-4955-B22A-9213A9536617}" dt="2026-04-13T22:51:13.247" v="683" actId="478"/>
-          <ac:spMkLst>
-            <pc:docMk/>
-            <pc:sldMk cId="4119995374" sldId="263"/>
-            <ac:spMk id="3" creationId="{D5D6B04F-5D6B-2752-7E34-2A74BB7D0FEE}"/>
-          </ac:spMkLst>
-        </pc:spChg>
         <pc:spChg chg="add mod">
           <ac:chgData name="Andres Flores" userId="cbb745aa252d2737" providerId="LiveId" clId="{5B02DD72-2521-4955-B22A-9213A9536617}" dt="2026-04-13T22:54:05.240" v="723" actId="164"/>
           <ac:spMkLst>
             <pc:docMk/>
             <pc:sldMk cId="4119995374" sldId="263"/>
             <ac:spMk id="4" creationId="{666FD7BB-FAFE-622D-FB10-749D5E2127F2}"/>
-          </ac:spMkLst>
-        </pc:spChg>
-        <pc:spChg chg="add mod">
-          <ac:chgData name="Andres Flores" userId="cbb745aa252d2737" providerId="LiveId" clId="{5B02DD72-2521-4955-B22A-9213A9536617}" dt="2026-04-13T22:51:20.880" v="685"/>
-          <ac:spMkLst>
-            <pc:docMk/>
-            <pc:sldMk cId="4119995374" sldId="263"/>
-            <ac:spMk id="6" creationId="{B7FDF252-A606-E2E5-9A7C-B9953281FB96}"/>
           </ac:spMkLst>
         </pc:spChg>
         <pc:spChg chg="add mod">
@@ -1750,30 +495,6 @@
             <ac:spMk id="9" creationId="{E6D37998-7BDF-E8FE-640C-50068E075C1F}"/>
           </ac:spMkLst>
         </pc:spChg>
-        <pc:spChg chg="add del mod">
-          <ac:chgData name="Andres Flores" userId="cbb745aa252d2737" providerId="LiveId" clId="{5B02DD72-2521-4955-B22A-9213A9536617}" dt="2026-04-13T22:53:35.915" v="718" actId="11529"/>
-          <ac:spMkLst>
-            <pc:docMk/>
-            <pc:sldMk cId="4119995374" sldId="263"/>
-            <ac:spMk id="14" creationId="{BC9616F6-26E4-37F8-1607-9F7BBDD9FAC9}"/>
-          </ac:spMkLst>
-        </pc:spChg>
-        <pc:spChg chg="mod">
-          <ac:chgData name="Andres Flores" userId="cbb745aa252d2737" providerId="LiveId" clId="{5B02DD72-2521-4955-B22A-9213A9536617}" dt="2026-04-13T22:54:06.594" v="724"/>
-          <ac:spMkLst>
-            <pc:docMk/>
-            <pc:sldMk cId="4119995374" sldId="263"/>
-            <ac:spMk id="18" creationId="{55150C10-5C44-E7ED-CBE0-A5085ECD1D60}"/>
-          </ac:spMkLst>
-        </pc:spChg>
-        <pc:spChg chg="mod">
-          <ac:chgData name="Andres Flores" userId="cbb745aa252d2737" providerId="LiveId" clId="{5B02DD72-2521-4955-B22A-9213A9536617}" dt="2026-04-13T22:54:06.594" v="724"/>
-          <ac:spMkLst>
-            <pc:docMk/>
-            <pc:sldMk cId="4119995374" sldId="263"/>
-            <ac:spMk id="21" creationId="{5E205B20-2220-D549-0BD6-A1282A1EBF10}"/>
-          </ac:spMkLst>
-        </pc:spChg>
         <pc:grpChg chg="add mod">
           <ac:chgData name="Andres Flores" userId="cbb745aa252d2737" providerId="LiveId" clId="{5B02DD72-2521-4955-B22A-9213A9536617}" dt="2026-04-13T22:54:05.240" v="723" actId="164"/>
           <ac:grpSpMkLst>
@@ -1782,36 +503,12 @@
             <ac:grpSpMk id="15" creationId="{4812A7DE-6B88-CC40-8848-497F40F75896}"/>
           </ac:grpSpMkLst>
         </pc:grpChg>
-        <pc:grpChg chg="add mod">
-          <ac:chgData name="Andres Flores" userId="cbb745aa252d2737" providerId="LiveId" clId="{5B02DD72-2521-4955-B22A-9213A9536617}" dt="2026-04-13T22:54:06.594" v="724"/>
-          <ac:grpSpMkLst>
-            <pc:docMk/>
-            <pc:sldMk cId="4119995374" sldId="263"/>
-            <ac:grpSpMk id="16" creationId="{F3EEFF97-49F7-5A79-23D6-97F0ED8DA0A1}"/>
-          </ac:grpSpMkLst>
-        </pc:grpChg>
         <pc:picChg chg="add mod">
           <ac:chgData name="Andres Flores" userId="cbb745aa252d2737" providerId="LiveId" clId="{5B02DD72-2521-4955-B22A-9213A9536617}" dt="2026-04-13T22:54:05.240" v="723" actId="164"/>
           <ac:picMkLst>
             <pc:docMk/>
             <pc:sldMk cId="4119995374" sldId="263"/>
             <ac:picMk id="2" creationId="{DC80D048-B432-E95D-2129-911ED3B5E72D}"/>
-          </ac:picMkLst>
-        </pc:picChg>
-        <pc:picChg chg="mod">
-          <ac:chgData name="Andres Flores" userId="cbb745aa252d2737" providerId="LiveId" clId="{5B02DD72-2521-4955-B22A-9213A9536617}" dt="2026-04-13T22:54:06.594" v="724"/>
-          <ac:picMkLst>
-            <pc:docMk/>
-            <pc:sldMk cId="4119995374" sldId="263"/>
-            <ac:picMk id="17" creationId="{8185FD72-ADB7-3A7A-CAE0-3EBD09756236}"/>
-          </ac:picMkLst>
-        </pc:picChg>
-        <pc:picChg chg="add del">
-          <ac:chgData name="Andres Flores" userId="cbb745aa252d2737" providerId="LiveId" clId="{5B02DD72-2521-4955-B22A-9213A9536617}" dt="2026-04-13T22:54:09.888" v="726" actId="21"/>
-          <ac:picMkLst>
-            <pc:docMk/>
-            <pc:sldMk cId="4119995374" sldId="263"/>
-            <ac:picMk id="23" creationId="{243A07AC-EDFC-EE6B-BE2B-0C3E425E4DA9}"/>
           </ac:picMkLst>
         </pc:picChg>
         <pc:cxnChg chg="add mod">
@@ -1823,14 +520,6 @@
           </ac:cxnSpMkLst>
         </pc:cxnChg>
         <pc:cxnChg chg="add mod">
-          <ac:chgData name="Andres Flores" userId="cbb745aa252d2737" providerId="LiveId" clId="{5B02DD72-2521-4955-B22A-9213A9536617}" dt="2026-04-13T22:51:20.880" v="685"/>
-          <ac:cxnSpMkLst>
-            <pc:docMk/>
-            <pc:sldMk cId="4119995374" sldId="263"/>
-            <ac:cxnSpMk id="7" creationId="{38692F56-DE52-B078-1B86-83355A58780A}"/>
-          </ac:cxnSpMkLst>
-        </pc:cxnChg>
-        <pc:cxnChg chg="add mod">
           <ac:chgData name="Andres Flores" userId="cbb745aa252d2737" providerId="LiveId" clId="{5B02DD72-2521-4955-B22A-9213A9536617}" dt="2026-04-13T22:54:05.240" v="723" actId="164"/>
           <ac:cxnSpMkLst>
             <pc:docMk/>
@@ -1838,22 +527,13 @@
             <ac:cxnSpMk id="8" creationId="{9310E68D-2B48-F5E4-5BD6-B67B3561CD2B}"/>
           </ac:cxnSpMkLst>
         </pc:cxnChg>
-        <pc:cxnChg chg="mod">
-          <ac:chgData name="Andres Flores" userId="cbb745aa252d2737" providerId="LiveId" clId="{5B02DD72-2521-4955-B22A-9213A9536617}" dt="2026-04-13T22:54:06.594" v="724"/>
-          <ac:cxnSpMkLst>
-            <pc:docMk/>
-            <pc:sldMk cId="4119995374" sldId="263"/>
-            <ac:cxnSpMk id="19" creationId="{1E9D5052-02F9-DF11-9970-1C8F095833D0}"/>
-          </ac:cxnSpMkLst>
-        </pc:cxnChg>
-        <pc:cxnChg chg="mod">
-          <ac:chgData name="Andres Flores" userId="cbb745aa252d2737" providerId="LiveId" clId="{5B02DD72-2521-4955-B22A-9213A9536617}" dt="2026-04-13T22:54:06.594" v="724"/>
-          <ac:cxnSpMkLst>
-            <pc:docMk/>
-            <pc:sldMk cId="4119995374" sldId="263"/>
-            <ac:cxnSpMk id="20" creationId="{E7DBFF4E-C785-9DF3-835A-8FDDC7792E79}"/>
-          </ac:cxnSpMkLst>
-        </pc:cxnChg>
+      </pc:sldChg>
+      <pc:sldChg chg="add del">
+        <pc:chgData name="Andres Flores" userId="cbb745aa252d2737" providerId="LiveId" clId="{5B02DD72-2521-4955-B22A-9213A9536617}" dt="2026-04-25T05:53:48.796" v="729" actId="2890"/>
+        <pc:sldMkLst>
+          <pc:docMk/>
+          <pc:sldMk cId="129621970" sldId="264"/>
+        </pc:sldMkLst>
       </pc:sldChg>
     </pc:docChg>
   </pc:docChgLst>
@@ -2007,7 +687,7 @@
           <a:p>
             <a:fld id="{7E742574-C446-4317-BDA1-9228D3A455E0}" type="datetimeFigureOut">
               <a:rPr lang="en-US" smtClean="0"/>
-              <a:t>4/13/2026</a:t>
+              <a:t>4/25/2026</a:t>
             </a:fld>
             <a:endParaRPr lang="en-US"/>
           </a:p>
@@ -2205,7 +885,7 @@
           <a:p>
             <a:fld id="{7E742574-C446-4317-BDA1-9228D3A455E0}" type="datetimeFigureOut">
               <a:rPr lang="en-US" smtClean="0"/>
-              <a:t>4/13/2026</a:t>
+              <a:t>4/25/2026</a:t>
             </a:fld>
             <a:endParaRPr lang="en-US"/>
           </a:p>
@@ -2413,7 +1093,7 @@
           <a:p>
             <a:fld id="{7E742574-C446-4317-BDA1-9228D3A455E0}" type="datetimeFigureOut">
               <a:rPr lang="en-US" smtClean="0"/>
-              <a:t>4/13/2026</a:t>
+              <a:t>4/25/2026</a:t>
             </a:fld>
             <a:endParaRPr lang="en-US"/>
           </a:p>
@@ -2611,7 +1291,7 @@
           <a:p>
             <a:fld id="{7E742574-C446-4317-BDA1-9228D3A455E0}" type="datetimeFigureOut">
               <a:rPr lang="en-US" smtClean="0"/>
-              <a:t>4/13/2026</a:t>
+              <a:t>4/25/2026</a:t>
             </a:fld>
             <a:endParaRPr lang="en-US"/>
           </a:p>
@@ -2886,7 +1566,7 @@
           <a:p>
             <a:fld id="{7E742574-C446-4317-BDA1-9228D3A455E0}" type="datetimeFigureOut">
               <a:rPr lang="en-US" smtClean="0"/>
-              <a:t>4/13/2026</a:t>
+              <a:t>4/25/2026</a:t>
             </a:fld>
             <a:endParaRPr lang="en-US"/>
           </a:p>
@@ -3151,7 +1831,7 @@
           <a:p>
             <a:fld id="{7E742574-C446-4317-BDA1-9228D3A455E0}" type="datetimeFigureOut">
               <a:rPr lang="en-US" smtClean="0"/>
-              <a:t>4/13/2026</a:t>
+              <a:t>4/25/2026</a:t>
             </a:fld>
             <a:endParaRPr lang="en-US"/>
           </a:p>
@@ -3563,7 +2243,7 @@
           <a:p>
             <a:fld id="{7E742574-C446-4317-BDA1-9228D3A455E0}" type="datetimeFigureOut">
               <a:rPr lang="en-US" smtClean="0"/>
-              <a:t>4/13/2026</a:t>
+              <a:t>4/25/2026</a:t>
             </a:fld>
             <a:endParaRPr lang="en-US"/>
           </a:p>
@@ -3704,7 +2384,7 @@
           <a:p>
             <a:fld id="{7E742574-C446-4317-BDA1-9228D3A455E0}" type="datetimeFigureOut">
               <a:rPr lang="en-US" smtClean="0"/>
-              <a:t>4/13/2026</a:t>
+              <a:t>4/25/2026</a:t>
             </a:fld>
             <a:endParaRPr lang="en-US"/>
           </a:p>
@@ -3817,7 +2497,7 @@
           <a:p>
             <a:fld id="{7E742574-C446-4317-BDA1-9228D3A455E0}" type="datetimeFigureOut">
               <a:rPr lang="en-US" smtClean="0"/>
-              <a:t>4/13/2026</a:t>
+              <a:t>4/25/2026</a:t>
             </a:fld>
             <a:endParaRPr lang="en-US"/>
           </a:p>
@@ -4128,7 +2808,7 @@
           <a:p>
             <a:fld id="{7E742574-C446-4317-BDA1-9228D3A455E0}" type="datetimeFigureOut">
               <a:rPr lang="en-US" smtClean="0"/>
-              <a:t>4/13/2026</a:t>
+              <a:t>4/25/2026</a:t>
             </a:fld>
             <a:endParaRPr lang="en-US"/>
           </a:p>
@@ -4416,7 +3096,7 @@
           <a:p>
             <a:fld id="{7E742574-C446-4317-BDA1-9228D3A455E0}" type="datetimeFigureOut">
               <a:rPr lang="en-US" smtClean="0"/>
-              <a:t>4/13/2026</a:t>
+              <a:t>4/25/2026</a:t>
             </a:fld>
             <a:endParaRPr lang="en-US"/>
           </a:p>
@@ -4657,7 +3337,7 @@
           <a:p>
             <a:fld id="{7E742574-C446-4317-BDA1-9228D3A455E0}" type="datetimeFigureOut">
               <a:rPr lang="en-US" smtClean="0"/>
-              <a:t>4/13/2026</a:t>
+              <a:t>4/25/2026</a:t>
             </a:fld>
             <a:endParaRPr lang="en-US"/>
           </a:p>
@@ -6894,10 +5574,10 @@
         </p:nvGrpSpPr>
         <p:grpSpPr>
           <a:xfrm>
-            <a:off x="2666998" y="0"/>
-            <a:ext cx="6858001" cy="6858000"/>
-            <a:chOff x="2666998" y="0"/>
-            <a:chExt cx="6858001" cy="6858000"/>
+            <a:off x="2661248" y="0"/>
+            <a:ext cx="6863751" cy="6858000"/>
+            <a:chOff x="2661248" y="0"/>
+            <a:chExt cx="6863751" cy="6858000"/>
           </a:xfrm>
         </p:grpSpPr>
         <p:grpSp>
@@ -6914,10 +5594,10 @@
           </p:nvGrpSpPr>
           <p:grpSpPr>
             <a:xfrm>
-              <a:off x="2666998" y="0"/>
-              <a:ext cx="6858001" cy="6858000"/>
-              <a:chOff x="2666998" y="0"/>
-              <a:chExt cx="6858001" cy="6858000"/>
+              <a:off x="2661248" y="0"/>
+              <a:ext cx="6863751" cy="6858000"/>
+              <a:chOff x="2661248" y="0"/>
+              <a:chExt cx="6863751" cy="6858000"/>
             </a:xfrm>
           </p:grpSpPr>
           <p:sp>
@@ -6941,7 +5621,7 @@
                 <a:avLst/>
               </a:prstGeom>
               <a:solidFill>
-                <a:schemeClr val="accent4"/>
+                <a:srgbClr val="00B0F0"/>
               </a:solidFill>
               <a:ln>
                 <a:noFill/>
@@ -6986,7 +5666,7 @@
             </p:nvSpPr>
             <p:spPr>
               <a:xfrm>
-                <a:off x="2666998" y="4348538"/>
+                <a:off x="2661248" y="4145338"/>
                 <a:ext cx="6858001" cy="2400657"/>
               </a:xfrm>
               <a:prstGeom prst="rect">
@@ -7030,19 +5710,20 @@
           </p:nvPicPr>
           <p:blipFill>
             <a:blip r:embed="rId2"/>
-            <a:srcRect l="12005" t="22315" r="10625" b="22315"/>
+            <a:srcRect l="12662" t="23105" r="11412" b="23214"/>
             <a:stretch>
               <a:fillRect/>
             </a:stretch>
           </p:blipFill>
           <p:spPr>
             <a:xfrm>
-              <a:off x="2714623" y="612911"/>
-              <a:ext cx="6762750" cy="3797300"/>
+              <a:off x="2771955" y="667109"/>
+              <a:ext cx="6636588" cy="3681429"/>
             </a:xfrm>
             <a:prstGeom prst="rect">
               <a:avLst/>
             </a:prstGeom>
+            <a:effectLst/>
           </p:spPr>
         </p:pic>
       </p:grpSp>

</xml_diff>